<commit_message>
New Top Window SVG
</commit_message>
<xml_diff>
--- a/Greenhouse Presentation.pptx
+++ b/Greenhouse Presentation.pptx
@@ -5,7 +5,7 @@
     <p:sldMasterId id="2147483648" r:id="rId1"/>
   </p:sldMasterIdLst>
   <p:notesMasterIdLst>
-    <p:notesMasterId r:id="rId11"/>
+    <p:notesMasterId r:id="rId12"/>
   </p:notesMasterIdLst>
   <p:sldIdLst>
     <p:sldId id="256" r:id="rId4"/>
@@ -15,6 +15,7 @@
     <p:sldId id="260" r:id="rId8"/>
     <p:sldId id="261" r:id="rId9"/>
     <p:sldId id="262" r:id="rId10"/>
+    <p:sldId id="263" r:id="rId11"/>
   </p:sldIdLst>
   <p:sldSz cx="12192000" cy="6858000"/>
   <p:notesSz cx="6858000" cy="9144000"/>
@@ -140,7 +141,7 @@
       </p:grpSpPr>
       <p:sp>
         <p:nvSpPr>
-          <p:cNvPr id="1502789689" name="Platzhalter für Überschrift 1"/>
+          <p:cNvPr id="285580604" name="Platzhalter für Überschrift 1"/>
           <p:cNvSpPr>
             <a:spLocks noGrp="1"/>
           </p:cNvSpPr>
@@ -174,7 +175,7 @@
       </p:sp>
       <p:sp>
         <p:nvSpPr>
-          <p:cNvPr id="2126010291" name="Datumsplatzhalter 2"/>
+          <p:cNvPr id="561217553" name="Datumsplatzhalter 2"/>
           <p:cNvSpPr>
             <a:spLocks noGrp="1"/>
           </p:cNvSpPr>
@@ -212,7 +213,7 @@
       </p:sp>
       <p:sp>
         <p:nvSpPr>
-          <p:cNvPr id="1207067955" name="Platzhalter für Folienbilder 3"/>
+          <p:cNvPr id="1996544713" name="Platzhalter für Folienbilder 3"/>
           <p:cNvSpPr>
             <a:spLocks noChangeAspect="1" noGrp="1" noRot="1"/>
           </p:cNvSpPr>
@@ -248,7 +249,7 @@
       </p:sp>
       <p:sp>
         <p:nvSpPr>
-          <p:cNvPr id="1788756955" name="Platzhalter für Notizen 4"/>
+          <p:cNvPr id="47106806" name="Platzhalter für Notizen 4"/>
           <p:cNvSpPr>
             <a:spLocks noGrp="1"/>
           </p:cNvSpPr>
@@ -322,7 +323,7 @@
       </p:sp>
       <p:sp>
         <p:nvSpPr>
-          <p:cNvPr id="971236748" name="Fußzeilenplatzhalter 5"/>
+          <p:cNvPr id="815466593" name="Fußzeilenplatzhalter 5"/>
           <p:cNvSpPr>
             <a:spLocks noGrp="1"/>
           </p:cNvSpPr>
@@ -356,7 +357,7 @@
       </p:sp>
       <p:sp>
         <p:nvSpPr>
-          <p:cNvPr id="340353710" name="Foliennummernplatzhalter 6"/>
+          <p:cNvPr id="1742054395" name="Foliennummernplatzhalter 6"/>
           <p:cNvSpPr>
             <a:spLocks noGrp="1"/>
           </p:cNvSpPr>
@@ -509,7 +510,7 @@
       </p:grpSpPr>
       <p:sp>
         <p:nvSpPr>
-          <p:cNvPr id="1158324000" name="Platzhalter für Folienbild 1"/>
+          <p:cNvPr id="1337528446" name="Platzhalter für Folienbild 1"/>
           <p:cNvSpPr>
             <a:spLocks noChangeAspect="1" noGrp="1" noRot="1"/>
           </p:cNvSpPr>
@@ -526,7 +527,7 @@
       </p:sp>
       <p:sp>
         <p:nvSpPr>
-          <p:cNvPr id="790676309" name="Platzhalter für Notizen 2"/>
+          <p:cNvPr id="55459868" name="Platzhalter für Notizen 2"/>
           <p:cNvSpPr>
             <a:spLocks noGrp="1"/>
           </p:cNvSpPr>
@@ -551,7 +552,7 @@
       </p:sp>
       <p:sp>
         <p:nvSpPr>
-          <p:cNvPr id="1826199779" name="Foliennummernplatzhalter 3"/>
+          <p:cNvPr id="2017910232" name="Foliennummernplatzhalter 3"/>
           <p:cNvSpPr>
             <a:spLocks noGrp="1"/>
           </p:cNvSpPr>
@@ -602,7 +603,7 @@
       </p:grpSpPr>
       <p:sp>
         <p:nvSpPr>
-          <p:cNvPr id="1600769554" name="Slide Image Placeholder 1"/>
+          <p:cNvPr id="1153706337" name="Slide Image Placeholder 1"/>
           <p:cNvSpPr>
             <a:spLocks noChangeAspect="1" noGrp="1" noRot="1"/>
           </p:cNvSpPr>
@@ -614,7 +615,7 @@
       </p:sp>
       <p:sp>
         <p:nvSpPr>
-          <p:cNvPr id="1101350555" name="Notes Placeholder 2"/>
+          <p:cNvPr id="32137216" name="Notes Placeholder 2"/>
           <p:cNvSpPr>
             <a:spLocks noGrp="1"/>
           </p:cNvSpPr>
@@ -636,7 +637,7 @@
       </p:sp>
       <p:sp>
         <p:nvSpPr>
-          <p:cNvPr id="1393365147" name="Slide Number Placeholder 3"/>
+          <p:cNvPr id="381953228" name="Slide Number Placeholder 3"/>
           <p:cNvSpPr>
             <a:spLocks noGrp="1"/>
           </p:cNvSpPr>
@@ -687,7 +688,7 @@
       </p:grpSpPr>
       <p:sp>
         <p:nvSpPr>
-          <p:cNvPr id="1183244209" name="Slide Image Placeholder 1"/>
+          <p:cNvPr id="1526474047" name="Slide Image Placeholder 1"/>
           <p:cNvSpPr>
             <a:spLocks noChangeAspect="1" noGrp="1" noRot="1"/>
           </p:cNvSpPr>
@@ -699,7 +700,7 @@
       </p:sp>
       <p:sp>
         <p:nvSpPr>
-          <p:cNvPr id="20390066" name="Notes Placeholder 2"/>
+          <p:cNvPr id="201036249" name="Notes Placeholder 2"/>
           <p:cNvSpPr>
             <a:spLocks noGrp="1"/>
           </p:cNvSpPr>
@@ -721,7 +722,7 @@
       </p:sp>
       <p:sp>
         <p:nvSpPr>
-          <p:cNvPr id="208201810" name="Slide Number Placeholder 3"/>
+          <p:cNvPr id="492284093" name="Slide Number Placeholder 3"/>
           <p:cNvSpPr>
             <a:spLocks noGrp="1"/>
           </p:cNvSpPr>
@@ -772,7 +773,7 @@
       </p:grpSpPr>
       <p:sp>
         <p:nvSpPr>
-          <p:cNvPr id="1043890115" name="Slide Image Placeholder 1"/>
+          <p:cNvPr id="1775616479" name="Slide Image Placeholder 1"/>
           <p:cNvSpPr>
             <a:spLocks noChangeAspect="1" noGrp="1" noRot="1"/>
           </p:cNvSpPr>
@@ -784,7 +785,7 @@
       </p:sp>
       <p:sp>
         <p:nvSpPr>
-          <p:cNvPr id="1560896703" name="Notes Placeholder 2"/>
+          <p:cNvPr id="785018012" name="Notes Placeholder 2"/>
           <p:cNvSpPr>
             <a:spLocks noGrp="1"/>
           </p:cNvSpPr>
@@ -806,7 +807,7 @@
       </p:sp>
       <p:sp>
         <p:nvSpPr>
-          <p:cNvPr id="1610864250" name="Slide Number Placeholder 3"/>
+          <p:cNvPr id="713577810" name="Slide Number Placeholder 3"/>
           <p:cNvSpPr>
             <a:spLocks noGrp="1"/>
           </p:cNvSpPr>
@@ -857,7 +858,7 @@
       </p:grpSpPr>
       <p:sp>
         <p:nvSpPr>
-          <p:cNvPr id="551182066" name="Slide Image Placeholder 1"/>
+          <p:cNvPr id="1380715000" name="Slide Image Placeholder 1"/>
           <p:cNvSpPr>
             <a:spLocks noChangeAspect="1" noGrp="1" noRot="1"/>
           </p:cNvSpPr>
@@ -869,7 +870,7 @@
       </p:sp>
       <p:sp>
         <p:nvSpPr>
-          <p:cNvPr id="10602448" name="Notes Placeholder 2"/>
+          <p:cNvPr id="29000333" name="Notes Placeholder 2"/>
           <p:cNvSpPr>
             <a:spLocks noGrp="1"/>
           </p:cNvSpPr>
@@ -891,7 +892,7 @@
       </p:sp>
       <p:sp>
         <p:nvSpPr>
-          <p:cNvPr id="1744043750" name="Slide Number Placeholder 3"/>
+          <p:cNvPr id="2110921131" name="Slide Number Placeholder 3"/>
           <p:cNvSpPr>
             <a:spLocks noGrp="1"/>
           </p:cNvSpPr>
@@ -942,7 +943,7 @@
       </p:grpSpPr>
       <p:sp>
         <p:nvSpPr>
-          <p:cNvPr id="1843115672" name="Slide Image Placeholder 1"/>
+          <p:cNvPr id="301558347" name="Slide Image Placeholder 1"/>
           <p:cNvSpPr>
             <a:spLocks noChangeAspect="1" noGrp="1" noRot="1"/>
           </p:cNvSpPr>
@@ -954,7 +955,7 @@
       </p:sp>
       <p:sp>
         <p:nvSpPr>
-          <p:cNvPr id="2094021111" name="Notes Placeholder 2"/>
+          <p:cNvPr id="70281945" name="Notes Placeholder 2"/>
           <p:cNvSpPr>
             <a:spLocks noGrp="1"/>
           </p:cNvSpPr>
@@ -976,7 +977,7 @@
       </p:sp>
       <p:sp>
         <p:nvSpPr>
-          <p:cNvPr id="1122359908" name="Slide Number Placeholder 3"/>
+          <p:cNvPr id="813606886" name="Slide Number Placeholder 3"/>
           <p:cNvSpPr>
             <a:spLocks noGrp="1"/>
           </p:cNvSpPr>
@@ -1027,6 +1028,91 @@
       </p:grpSpPr>
       <p:sp>
         <p:nvSpPr>
+          <p:cNvPr id="413017360" name="Slide Image Placeholder 1"/>
+          <p:cNvSpPr>
+            <a:spLocks noChangeAspect="1" noGrp="1" noRot="1"/>
+          </p:cNvSpPr>
+          <p:nvPr>
+            <p:ph type="sldImg"/>
+          </p:nvPr>
+        </p:nvSpPr>
+        <p:spPr bwMode="auto"/>
+      </p:sp>
+      <p:sp>
+        <p:nvSpPr>
+          <p:cNvPr id="1363597057" name="Notes Placeholder 2"/>
+          <p:cNvSpPr>
+            <a:spLocks noGrp="1"/>
+          </p:cNvSpPr>
+          <p:nvPr>
+            <p:ph type="body" idx="1"/>
+          </p:nvPr>
+        </p:nvSpPr>
+        <p:spPr bwMode="auto"/>
+        <p:txBody>
+          <a:bodyPr/>
+          <a:lstStyle/>
+          <a:p>
+            <a:pPr>
+              <a:defRPr/>
+            </a:pPr>
+            <a:endParaRPr/>
+          </a:p>
+        </p:txBody>
+      </p:sp>
+      <p:sp>
+        <p:nvSpPr>
+          <p:cNvPr id="1396722900" name="Slide Number Placeholder 3"/>
+          <p:cNvSpPr>
+            <a:spLocks noGrp="1"/>
+          </p:cNvSpPr>
+          <p:nvPr>
+            <p:ph type="sldNum" sz="quarter" idx="10"/>
+          </p:nvPr>
+        </p:nvSpPr>
+        <p:spPr bwMode="auto"/>
+        <p:txBody>
+          <a:bodyPr/>
+          <a:lstStyle/>
+          <a:p>
+            <a:pPr>
+              <a:defRPr/>
+            </a:pPr>
+            <a:fld id="{8A7ABA56-F0A9-0673-D9C6-533F696A8ABE}" type="slidenum">
+              <a:rPr/>
+              <a:t/>
+            </a:fld>
+            <a:endParaRPr/>
+          </a:p>
+        </p:txBody>
+      </p:sp>
+    </p:spTree>
+  </p:cSld>
+  <p:clrMapOvr>
+    <a:masterClrMapping/>
+  </p:clrMapOvr>
+</p:notes>
+</file>
+
+<file path=ppt/notesSlides/notesSlide8.xml><?xml version="1.0" encoding="utf-8"?>
+<p:notes xmlns:a="http://schemas.openxmlformats.org/drawingml/2006/main" xmlns:r="http://schemas.openxmlformats.org/officeDocument/2006/relationships" xmlns:p="http://schemas.openxmlformats.org/presentationml/2006/main" xmlns:m="http://schemas.openxmlformats.org/officeDocument/2006/math" xmlns:w="http://schemas.openxmlformats.org/wordprocessingml/2006/main">
+  <p:cSld name="">
+    <p:spTree>
+      <p:nvGrpSpPr>
+        <p:cNvPr id="1" name=""/>
+        <p:cNvGrpSpPr/>
+        <p:nvPr/>
+      </p:nvGrpSpPr>
+      <p:grpSpPr bwMode="auto">
+        <a:xfrm>
+          <a:off x="0" y="0"/>
+          <a:ext cx="0" cy="0"/>
+          <a:chOff x="0" y="0"/>
+          <a:chExt cx="0" cy="0"/>
+        </a:xfrm>
+      </p:grpSpPr>
+      <p:sp>
+        <p:nvSpPr>
           <p:cNvPr id="2" name="Slide Image Placeholder 1"/>
           <p:cNvSpPr>
             <a:spLocks noChangeAspect="1" noGrp="1" noRot="1"/>
@@ -1077,7 +1163,7 @@
             <a:pPr>
               <a:defRPr/>
             </a:pPr>
-            <a:fld id="{8A7ABA56-F0A9-0673-D9C6-533F696A8ABE}" type="slidenum">
+            <a:fld id="{AC9F5722-BC0D-F453-543C-68CC44FCD01F}" type="slidenum">
               <a:rPr/>
               <a:t/>
             </a:fld>
@@ -1112,7 +1198,7 @@
       </p:grpSpPr>
       <p:sp>
         <p:nvSpPr>
-          <p:cNvPr id="21340518" name="Titel 1"/>
+          <p:cNvPr id="862024368" name="Titel 1"/>
           <p:cNvSpPr>
             <a:spLocks noGrp="1"/>
           </p:cNvSpPr>
@@ -1147,7 +1233,7 @@
       </p:sp>
       <p:sp>
         <p:nvSpPr>
-          <p:cNvPr id="1077363935" name="Untertitel 2"/>
+          <p:cNvPr id="556195656" name="Untertitel 2"/>
           <p:cNvSpPr>
             <a:spLocks noGrp="1"/>
           </p:cNvSpPr>
@@ -1215,7 +1301,7 @@
       </p:sp>
       <p:sp>
         <p:nvSpPr>
-          <p:cNvPr id="20663183" name="Datumsplatzhalter 3"/>
+          <p:cNvPr id="1205139724" name="Datumsplatzhalter 3"/>
           <p:cNvSpPr>
             <a:spLocks noGrp="1"/>
           </p:cNvSpPr>
@@ -1241,7 +1327,7 @@
       </p:sp>
       <p:sp>
         <p:nvSpPr>
-          <p:cNvPr id="143407858" name="Fußzeilenplatzhalter 4"/>
+          <p:cNvPr id="1082425614" name="Fußzeilenplatzhalter 4"/>
           <p:cNvSpPr>
             <a:spLocks noGrp="1"/>
           </p:cNvSpPr>
@@ -1263,7 +1349,7 @@
       </p:sp>
       <p:sp>
         <p:nvSpPr>
-          <p:cNvPr id="967396591" name="Foliennummernplatzhalter 5"/>
+          <p:cNvPr id="1973972363" name="Foliennummernplatzhalter 5"/>
           <p:cNvSpPr>
             <a:spLocks noGrp="1"/>
           </p:cNvSpPr>
@@ -1314,7 +1400,7 @@
       </p:grpSpPr>
       <p:sp>
         <p:nvSpPr>
-          <p:cNvPr id="997594692" name="Titel 1"/>
+          <p:cNvPr id="1763644636" name="Titel 1"/>
           <p:cNvSpPr>
             <a:spLocks noGrp="1"/>
           </p:cNvSpPr>
@@ -1340,7 +1426,7 @@
       </p:sp>
       <p:sp>
         <p:nvSpPr>
-          <p:cNvPr id="1807025449" name="Vertikaler Textplatzhalter 2"/>
+          <p:cNvPr id="1243528316" name="Vertikaler Textplatzhalter 2"/>
           <p:cNvSpPr>
             <a:spLocks noGrp="1"/>
           </p:cNvSpPr>
@@ -1406,7 +1492,7 @@
       </p:sp>
       <p:sp>
         <p:nvSpPr>
-          <p:cNvPr id="393670278" name="Datumsplatzhalter 3"/>
+          <p:cNvPr id="1000254672" name="Datumsplatzhalter 3"/>
           <p:cNvSpPr>
             <a:spLocks noGrp="1"/>
           </p:cNvSpPr>
@@ -1432,7 +1518,7 @@
       </p:sp>
       <p:sp>
         <p:nvSpPr>
-          <p:cNvPr id="1273045109" name="Fußzeilenplatzhalter 4"/>
+          <p:cNvPr id="100896532" name="Fußzeilenplatzhalter 4"/>
           <p:cNvSpPr>
             <a:spLocks noGrp="1"/>
           </p:cNvSpPr>
@@ -1454,7 +1540,7 @@
       </p:sp>
       <p:sp>
         <p:nvSpPr>
-          <p:cNvPr id="1566498482" name="Foliennummernplatzhalter 5"/>
+          <p:cNvPr id="1910522236" name="Foliennummernplatzhalter 5"/>
           <p:cNvSpPr>
             <a:spLocks noGrp="1"/>
           </p:cNvSpPr>
@@ -1505,7 +1591,7 @@
       </p:grpSpPr>
       <p:sp>
         <p:nvSpPr>
-          <p:cNvPr id="1730882001" name="Vertikaler Titel 1"/>
+          <p:cNvPr id="1797191632" name="Vertikaler Titel 1"/>
           <p:cNvSpPr>
             <a:spLocks noGrp="1"/>
           </p:cNvSpPr>
@@ -1536,7 +1622,7 @@
       </p:sp>
       <p:sp>
         <p:nvSpPr>
-          <p:cNvPr id="1554089962" name="Vertikaler Textplatzhalter 2"/>
+          <p:cNvPr id="1780159524" name="Vertikaler Textplatzhalter 2"/>
           <p:cNvSpPr>
             <a:spLocks noGrp="1"/>
           </p:cNvSpPr>
@@ -1607,7 +1693,7 @@
       </p:sp>
       <p:sp>
         <p:nvSpPr>
-          <p:cNvPr id="2119724015" name="Datumsplatzhalter 3"/>
+          <p:cNvPr id="962808441" name="Datumsplatzhalter 3"/>
           <p:cNvSpPr>
             <a:spLocks noGrp="1"/>
           </p:cNvSpPr>
@@ -1633,7 +1719,7 @@
       </p:sp>
       <p:sp>
         <p:nvSpPr>
-          <p:cNvPr id="1785737951" name="Fußzeilenplatzhalter 4"/>
+          <p:cNvPr id="1445114607" name="Fußzeilenplatzhalter 4"/>
           <p:cNvSpPr>
             <a:spLocks noGrp="1"/>
           </p:cNvSpPr>
@@ -1655,7 +1741,7 @@
       </p:sp>
       <p:sp>
         <p:nvSpPr>
-          <p:cNvPr id="866819315" name="Foliennummernplatzhalter 5"/>
+          <p:cNvPr id="1302264378" name="Foliennummernplatzhalter 5"/>
           <p:cNvSpPr>
             <a:spLocks noGrp="1"/>
           </p:cNvSpPr>
@@ -1706,7 +1792,7 @@
       </p:grpSpPr>
       <p:sp>
         <p:nvSpPr>
-          <p:cNvPr id="2014302499" name="Titel 1"/>
+          <p:cNvPr id="804888210" name="Titel 1"/>
           <p:cNvSpPr>
             <a:spLocks noGrp="1"/>
           </p:cNvSpPr>
@@ -1732,7 +1818,7 @@
       </p:sp>
       <p:sp>
         <p:nvSpPr>
-          <p:cNvPr id="699928627" name="Inhaltsplatzhalter 2"/>
+          <p:cNvPr id="1617896896" name="Inhaltsplatzhalter 2"/>
           <p:cNvSpPr>
             <a:spLocks noGrp="1"/>
           </p:cNvSpPr>
@@ -1798,7 +1884,7 @@
       </p:sp>
       <p:sp>
         <p:nvSpPr>
-          <p:cNvPr id="825149303" name="Datumsplatzhalter 3"/>
+          <p:cNvPr id="1303227325" name="Datumsplatzhalter 3"/>
           <p:cNvSpPr>
             <a:spLocks noGrp="1"/>
           </p:cNvSpPr>
@@ -1824,7 +1910,7 @@
       </p:sp>
       <p:sp>
         <p:nvSpPr>
-          <p:cNvPr id="900524787" name="Fußzeilenplatzhalter 4"/>
+          <p:cNvPr id="207054327" name="Fußzeilenplatzhalter 4"/>
           <p:cNvSpPr>
             <a:spLocks noGrp="1"/>
           </p:cNvSpPr>
@@ -1846,7 +1932,7 @@
       </p:sp>
       <p:sp>
         <p:nvSpPr>
-          <p:cNvPr id="722098059" name="Foliennummernplatzhalter 5"/>
+          <p:cNvPr id="518397640" name="Foliennummernplatzhalter 5"/>
           <p:cNvSpPr>
             <a:spLocks noGrp="1"/>
           </p:cNvSpPr>
@@ -1897,7 +1983,7 @@
       </p:grpSpPr>
       <p:sp>
         <p:nvSpPr>
-          <p:cNvPr id="1297553926" name="Titel 1"/>
+          <p:cNvPr id="369795375" name="Titel 1"/>
           <p:cNvSpPr>
             <a:spLocks noGrp="1"/>
           </p:cNvSpPr>
@@ -1932,7 +2018,7 @@
       </p:sp>
       <p:sp>
         <p:nvSpPr>
-          <p:cNvPr id="2004181821" name="Textplatzhalter 2"/>
+          <p:cNvPr id="1463743844" name="Textplatzhalter 2"/>
           <p:cNvSpPr>
             <a:spLocks noGrp="1"/>
           </p:cNvSpPr>
@@ -2054,7 +2140,7 @@
       </p:sp>
       <p:sp>
         <p:nvSpPr>
-          <p:cNvPr id="1736649336" name="Datumsplatzhalter 3"/>
+          <p:cNvPr id="1503865613" name="Datumsplatzhalter 3"/>
           <p:cNvSpPr>
             <a:spLocks noGrp="1"/>
           </p:cNvSpPr>
@@ -2080,7 +2166,7 @@
       </p:sp>
       <p:sp>
         <p:nvSpPr>
-          <p:cNvPr id="866478057" name="Fußzeilenplatzhalter 4"/>
+          <p:cNvPr id="962142693" name="Fußzeilenplatzhalter 4"/>
           <p:cNvSpPr>
             <a:spLocks noGrp="1"/>
           </p:cNvSpPr>
@@ -2102,7 +2188,7 @@
       </p:sp>
       <p:sp>
         <p:nvSpPr>
-          <p:cNvPr id="2035940487" name="Foliennummernplatzhalter 5"/>
+          <p:cNvPr id="1480716223" name="Foliennummernplatzhalter 5"/>
           <p:cNvSpPr>
             <a:spLocks noGrp="1"/>
           </p:cNvSpPr>
@@ -2153,7 +2239,7 @@
       </p:grpSpPr>
       <p:sp>
         <p:nvSpPr>
-          <p:cNvPr id="697934573" name="Titel 1"/>
+          <p:cNvPr id="1819295976" name="Titel 1"/>
           <p:cNvSpPr>
             <a:spLocks noGrp="1"/>
           </p:cNvSpPr>
@@ -2179,7 +2265,7 @@
       </p:sp>
       <p:sp>
         <p:nvSpPr>
-          <p:cNvPr id="223160765" name="Inhaltsplatzhalter 2"/>
+          <p:cNvPr id="179953275" name="Inhaltsplatzhalter 2"/>
           <p:cNvSpPr>
             <a:spLocks noGrp="1"/>
           </p:cNvSpPr>
@@ -2250,7 +2336,7 @@
       </p:sp>
       <p:sp>
         <p:nvSpPr>
-          <p:cNvPr id="573419148" name="Inhaltsplatzhalter 3"/>
+          <p:cNvPr id="1792507406" name="Inhaltsplatzhalter 3"/>
           <p:cNvSpPr>
             <a:spLocks noGrp="1"/>
           </p:cNvSpPr>
@@ -2321,7 +2407,7 @@
       </p:sp>
       <p:sp>
         <p:nvSpPr>
-          <p:cNvPr id="1324661856" name="Datumsplatzhalter 4"/>
+          <p:cNvPr id="1446208756" name="Datumsplatzhalter 4"/>
           <p:cNvSpPr>
             <a:spLocks noGrp="1"/>
           </p:cNvSpPr>
@@ -2347,7 +2433,7 @@
       </p:sp>
       <p:sp>
         <p:nvSpPr>
-          <p:cNvPr id="1259235489" name="Fußzeilenplatzhalter 5"/>
+          <p:cNvPr id="1649478394" name="Fußzeilenplatzhalter 5"/>
           <p:cNvSpPr>
             <a:spLocks noGrp="1"/>
           </p:cNvSpPr>
@@ -2369,7 +2455,7 @@
       </p:sp>
       <p:sp>
         <p:nvSpPr>
-          <p:cNvPr id="140718250" name="Foliennummernplatzhalter 6"/>
+          <p:cNvPr id="1504101493" name="Foliennummernplatzhalter 6"/>
           <p:cNvSpPr>
             <a:spLocks noGrp="1"/>
           </p:cNvSpPr>
@@ -2420,7 +2506,7 @@
       </p:grpSpPr>
       <p:sp>
         <p:nvSpPr>
-          <p:cNvPr id="620912208" name="Titel 1"/>
+          <p:cNvPr id="583209519" name="Titel 1"/>
           <p:cNvSpPr>
             <a:spLocks noGrp="1"/>
           </p:cNvSpPr>
@@ -2451,7 +2537,7 @@
       </p:sp>
       <p:sp>
         <p:nvSpPr>
-          <p:cNvPr id="923993851" name="Textplatzhalter 2"/>
+          <p:cNvPr id="1309248516" name="Textplatzhalter 2"/>
           <p:cNvSpPr>
             <a:spLocks noGrp="1"/>
           </p:cNvSpPr>
@@ -2519,7 +2605,7 @@
       </p:sp>
       <p:sp>
         <p:nvSpPr>
-          <p:cNvPr id="1353431666" name="Inhaltsplatzhalter 3"/>
+          <p:cNvPr id="999984835" name="Inhaltsplatzhalter 3"/>
           <p:cNvSpPr>
             <a:spLocks noGrp="1"/>
           </p:cNvSpPr>
@@ -2590,7 +2676,7 @@
       </p:sp>
       <p:sp>
         <p:nvSpPr>
-          <p:cNvPr id="1192162251" name="Textplatzhalter 4"/>
+          <p:cNvPr id="224428000" name="Textplatzhalter 4"/>
           <p:cNvSpPr>
             <a:spLocks noGrp="1"/>
           </p:cNvSpPr>
@@ -2658,7 +2744,7 @@
       </p:sp>
       <p:sp>
         <p:nvSpPr>
-          <p:cNvPr id="2005940291" name="Inhaltsplatzhalter 5"/>
+          <p:cNvPr id="939144659" name="Inhaltsplatzhalter 5"/>
           <p:cNvSpPr>
             <a:spLocks noGrp="1"/>
           </p:cNvSpPr>
@@ -2729,7 +2815,7 @@
       </p:sp>
       <p:sp>
         <p:nvSpPr>
-          <p:cNvPr id="136860995" name="Datumsplatzhalter 6"/>
+          <p:cNvPr id="1175261118" name="Datumsplatzhalter 6"/>
           <p:cNvSpPr>
             <a:spLocks noGrp="1"/>
           </p:cNvSpPr>
@@ -2755,7 +2841,7 @@
       </p:sp>
       <p:sp>
         <p:nvSpPr>
-          <p:cNvPr id="92196683" name="Fußzeilenplatzhalter 7"/>
+          <p:cNvPr id="864065922" name="Fußzeilenplatzhalter 7"/>
           <p:cNvSpPr>
             <a:spLocks noGrp="1"/>
           </p:cNvSpPr>
@@ -2777,7 +2863,7 @@
       </p:sp>
       <p:sp>
         <p:nvSpPr>
-          <p:cNvPr id="1880925093" name="Foliennummernplatzhalter 8"/>
+          <p:cNvPr id="1290901558" name="Foliennummernplatzhalter 8"/>
           <p:cNvSpPr>
             <a:spLocks noGrp="1"/>
           </p:cNvSpPr>
@@ -2828,7 +2914,7 @@
       </p:grpSpPr>
       <p:sp>
         <p:nvSpPr>
-          <p:cNvPr id="1487767477" name="Titel 1"/>
+          <p:cNvPr id="571677311" name="Titel 1"/>
           <p:cNvSpPr>
             <a:spLocks noGrp="1"/>
           </p:cNvSpPr>
@@ -2854,7 +2940,7 @@
       </p:sp>
       <p:sp>
         <p:nvSpPr>
-          <p:cNvPr id="28922862" name="Datumsplatzhalter 2"/>
+          <p:cNvPr id="1629687580" name="Datumsplatzhalter 2"/>
           <p:cNvSpPr>
             <a:spLocks noGrp="1"/>
           </p:cNvSpPr>
@@ -2880,7 +2966,7 @@
       </p:sp>
       <p:sp>
         <p:nvSpPr>
-          <p:cNvPr id="424684982" name="Fußzeilenplatzhalter 3"/>
+          <p:cNvPr id="747790419" name="Fußzeilenplatzhalter 3"/>
           <p:cNvSpPr>
             <a:spLocks noGrp="1"/>
           </p:cNvSpPr>
@@ -2902,7 +2988,7 @@
       </p:sp>
       <p:sp>
         <p:nvSpPr>
-          <p:cNvPr id="642105531" name="Foliennummernplatzhalter 4"/>
+          <p:cNvPr id="588547775" name="Foliennummernplatzhalter 4"/>
           <p:cNvSpPr>
             <a:spLocks noGrp="1"/>
           </p:cNvSpPr>
@@ -2953,7 +3039,7 @@
       </p:grpSpPr>
       <p:sp>
         <p:nvSpPr>
-          <p:cNvPr id="943836938" name="Datumsplatzhalter 1"/>
+          <p:cNvPr id="1334552704" name="Datumsplatzhalter 1"/>
           <p:cNvSpPr>
             <a:spLocks noGrp="1"/>
           </p:cNvSpPr>
@@ -2979,7 +3065,7 @@
       </p:sp>
       <p:sp>
         <p:nvSpPr>
-          <p:cNvPr id="899870307" name="Fußzeilenplatzhalter 2"/>
+          <p:cNvPr id="126005033" name="Fußzeilenplatzhalter 2"/>
           <p:cNvSpPr>
             <a:spLocks noGrp="1"/>
           </p:cNvSpPr>
@@ -3001,7 +3087,7 @@
       </p:sp>
       <p:sp>
         <p:nvSpPr>
-          <p:cNvPr id="1742104466" name="Foliennummernplatzhalter 3"/>
+          <p:cNvPr id="2092618184" name="Foliennummernplatzhalter 3"/>
           <p:cNvSpPr>
             <a:spLocks noGrp="1"/>
           </p:cNvSpPr>
@@ -3052,7 +3138,7 @@
       </p:grpSpPr>
       <p:sp>
         <p:nvSpPr>
-          <p:cNvPr id="1066141117" name="Titel 1"/>
+          <p:cNvPr id="1045388710" name="Titel 1"/>
           <p:cNvSpPr>
             <a:spLocks noGrp="1"/>
           </p:cNvSpPr>
@@ -3087,7 +3173,7 @@
       </p:sp>
       <p:sp>
         <p:nvSpPr>
-          <p:cNvPr id="1159507404" name="Inhaltsplatzhalter 2"/>
+          <p:cNvPr id="1400089125" name="Inhaltsplatzhalter 2"/>
           <p:cNvSpPr>
             <a:spLocks noGrp="1"/>
           </p:cNvSpPr>
@@ -3186,7 +3272,7 @@
       </p:sp>
       <p:sp>
         <p:nvSpPr>
-          <p:cNvPr id="298301376" name="Textplatzhalter 3"/>
+          <p:cNvPr id="2042268831" name="Textplatzhalter 3"/>
           <p:cNvSpPr>
             <a:spLocks noGrp="1"/>
           </p:cNvSpPr>
@@ -3254,7 +3340,7 @@
       </p:sp>
       <p:sp>
         <p:nvSpPr>
-          <p:cNvPr id="2049176388" name="Datumsplatzhalter 4"/>
+          <p:cNvPr id="1334185951" name="Datumsplatzhalter 4"/>
           <p:cNvSpPr>
             <a:spLocks noGrp="1"/>
           </p:cNvSpPr>
@@ -3280,7 +3366,7 @@
       </p:sp>
       <p:sp>
         <p:nvSpPr>
-          <p:cNvPr id="642786797" name="Fußzeilenplatzhalter 5"/>
+          <p:cNvPr id="327395472" name="Fußzeilenplatzhalter 5"/>
           <p:cNvSpPr>
             <a:spLocks noGrp="1"/>
           </p:cNvSpPr>
@@ -3302,7 +3388,7 @@
       </p:sp>
       <p:sp>
         <p:nvSpPr>
-          <p:cNvPr id="1897892675" name="Foliennummernplatzhalter 6"/>
+          <p:cNvPr id="951324684" name="Foliennummernplatzhalter 6"/>
           <p:cNvSpPr>
             <a:spLocks noGrp="1"/>
           </p:cNvSpPr>
@@ -3353,7 +3439,7 @@
       </p:grpSpPr>
       <p:sp>
         <p:nvSpPr>
-          <p:cNvPr id="1938053286" name="Titel 1"/>
+          <p:cNvPr id="23647851" name="Titel 1"/>
           <p:cNvSpPr>
             <a:spLocks noGrp="1"/>
           </p:cNvSpPr>
@@ -3388,7 +3474,7 @@
       </p:sp>
       <p:sp>
         <p:nvSpPr>
-          <p:cNvPr id="1285012470" name="Bildplatzhalter 2"/>
+          <p:cNvPr id="1012959033" name="Bildplatzhalter 2"/>
           <p:cNvSpPr>
             <a:spLocks noChangeAspect="1" noGrp="1"/>
           </p:cNvSpPr>
@@ -3456,7 +3542,7 @@
       </p:sp>
       <p:sp>
         <p:nvSpPr>
-          <p:cNvPr id="1937927463" name="Textplatzhalter 3"/>
+          <p:cNvPr id="576565348" name="Textplatzhalter 3"/>
           <p:cNvSpPr>
             <a:spLocks noGrp="1"/>
           </p:cNvSpPr>
@@ -3524,7 +3610,7 @@
       </p:sp>
       <p:sp>
         <p:nvSpPr>
-          <p:cNvPr id="2127171230" name="Datumsplatzhalter 4"/>
+          <p:cNvPr id="1900909619" name="Datumsplatzhalter 4"/>
           <p:cNvSpPr>
             <a:spLocks noGrp="1"/>
           </p:cNvSpPr>
@@ -3550,7 +3636,7 @@
       </p:sp>
       <p:sp>
         <p:nvSpPr>
-          <p:cNvPr id="317904976" name="Fußzeilenplatzhalter 5"/>
+          <p:cNvPr id="1796611708" name="Fußzeilenplatzhalter 5"/>
           <p:cNvSpPr>
             <a:spLocks noGrp="1"/>
           </p:cNvSpPr>
@@ -3572,7 +3658,7 @@
       </p:sp>
       <p:sp>
         <p:nvSpPr>
-          <p:cNvPr id="850567607" name="Foliennummernplatzhalter 6"/>
+          <p:cNvPr id="609493392" name="Foliennummernplatzhalter 6"/>
           <p:cNvSpPr>
             <a:spLocks noGrp="1"/>
           </p:cNvSpPr>
@@ -3628,7 +3714,7 @@
       </p:grpSpPr>
       <p:sp>
         <p:nvSpPr>
-          <p:cNvPr id="1508383912" name="Titelplatzhalter 1"/>
+          <p:cNvPr id="1923857862" name="Titelplatzhalter 1"/>
           <p:cNvSpPr>
             <a:spLocks noGrp="1"/>
           </p:cNvSpPr>
@@ -3664,7 +3750,7 @@
       </p:sp>
       <p:sp>
         <p:nvSpPr>
-          <p:cNvPr id="449644255" name="Textplatzhalter 2"/>
+          <p:cNvPr id="1398243834" name="Textplatzhalter 2"/>
           <p:cNvSpPr>
             <a:spLocks noGrp="1"/>
           </p:cNvSpPr>
@@ -3740,7 +3826,7 @@
       </p:sp>
       <p:sp>
         <p:nvSpPr>
-          <p:cNvPr id="1428925837" name="Datumsplatzhalter 3"/>
+          <p:cNvPr id="1505991818" name="Datumsplatzhalter 3"/>
           <p:cNvSpPr>
             <a:spLocks noGrp="1"/>
           </p:cNvSpPr>
@@ -3784,7 +3870,7 @@
       </p:sp>
       <p:sp>
         <p:nvSpPr>
-          <p:cNvPr id="27551658" name="Fußzeilenplatzhalter 4"/>
+          <p:cNvPr id="1783833423" name="Fußzeilenplatzhalter 4"/>
           <p:cNvSpPr>
             <a:spLocks noGrp="1"/>
           </p:cNvSpPr>
@@ -3824,7 +3910,7 @@
       </p:sp>
       <p:sp>
         <p:nvSpPr>
-          <p:cNvPr id="1714270603" name="Foliennummernplatzhalter 5"/>
+          <p:cNvPr id="1049063322" name="Foliennummernplatzhalter 5"/>
           <p:cNvSpPr>
             <a:spLocks noGrp="1"/>
           </p:cNvSpPr>
@@ -4184,7 +4270,7 @@
       </p:grpSpPr>
       <p:sp>
         <p:nvSpPr>
-          <p:cNvPr id="1864266357" name="Titel 1"/>
+          <p:cNvPr id="1928858105" name="Titel 1"/>
           <p:cNvSpPr>
             <a:spLocks noGrp="1"/>
           </p:cNvSpPr>
@@ -4210,7 +4296,7 @@
       </p:sp>
       <p:sp>
         <p:nvSpPr>
-          <p:cNvPr id="10053082" name="Untertitel 2"/>
+          <p:cNvPr id="772827212" name="Untertitel 2"/>
           <p:cNvSpPr>
             <a:spLocks noGrp="1"/>
           </p:cNvSpPr>
@@ -4269,7 +4355,7 @@
       </p:grpSpPr>
       <p:sp>
         <p:nvSpPr>
-          <p:cNvPr id="835925731" name="Titel 1"/>
+          <p:cNvPr id="1721225868" name="Titel 1"/>
           <p:cNvSpPr>
             <a:spLocks noGrp="1"/>
           </p:cNvSpPr>
@@ -4295,7 +4381,7 @@
       </p:sp>
       <p:pic>
         <p:nvPicPr>
-          <p:cNvPr id="609688392" name=""/>
+          <p:cNvPr id="1232710256" name=""/>
           <p:cNvPicPr>
             <a:picLocks noChangeAspect="1"/>
           </p:cNvPicPr>
@@ -4317,7 +4403,7 @@
       </p:pic>
       <p:sp>
         <p:nvSpPr>
-          <p:cNvPr id="796753516" name=""/>
+          <p:cNvPr id="704728726" name=""/>
           <p:cNvSpPr txBox="1"/>
           <p:nvPr/>
         </p:nvSpPr>
@@ -4408,7 +4494,7 @@
       </p:grpSpPr>
       <p:sp>
         <p:nvSpPr>
-          <p:cNvPr id="1079505027" name="Titel 1"/>
+          <p:cNvPr id="2041253543" name="Titel 1"/>
           <p:cNvSpPr>
             <a:spLocks noGrp="1"/>
           </p:cNvSpPr>
@@ -4434,7 +4520,7 @@
       </p:sp>
       <p:pic>
         <p:nvPicPr>
-          <p:cNvPr id="1625518886" name=""/>
+          <p:cNvPr id="516475653" name=""/>
           <p:cNvPicPr>
             <a:picLocks noChangeAspect="1"/>
           </p:cNvPicPr>
@@ -4456,7 +4542,7 @@
       </p:pic>
       <p:pic>
         <p:nvPicPr>
-          <p:cNvPr id="2107968497" name=""/>
+          <p:cNvPr id="1995736872" name=""/>
           <p:cNvPicPr>
             <a:picLocks noChangeAspect="1"/>
           </p:cNvPicPr>
@@ -4478,7 +4564,7 @@
       </p:pic>
       <p:pic>
         <p:nvPicPr>
-          <p:cNvPr id="1876715740" name=""/>
+          <p:cNvPr id="1071820764" name=""/>
           <p:cNvPicPr>
             <a:picLocks noChangeAspect="1"/>
           </p:cNvPicPr>
@@ -4500,7 +4586,7 @@
       </p:pic>
       <p:pic>
         <p:nvPicPr>
-          <p:cNvPr id="67823622" name=""/>
+          <p:cNvPr id="1975950784" name=""/>
           <p:cNvPicPr>
             <a:picLocks noChangeAspect="1"/>
           </p:cNvPicPr>
@@ -4522,7 +4608,7 @@
       </p:pic>
       <p:pic>
         <p:nvPicPr>
-          <p:cNvPr id="1992476976" name=""/>
+          <p:cNvPr id="2145021910" name=""/>
           <p:cNvPicPr>
             <a:picLocks noChangeAspect="1"/>
           </p:cNvPicPr>
@@ -4544,7 +4630,7 @@
       </p:pic>
       <p:sp>
         <p:nvSpPr>
-          <p:cNvPr id="940970352" name=""/>
+          <p:cNvPr id="1036039638" name=""/>
           <p:cNvSpPr txBox="1"/>
           <p:nvPr/>
         </p:nvSpPr>
@@ -4576,7 +4662,7 @@
       </p:sp>
       <p:sp>
         <p:nvSpPr>
-          <p:cNvPr id="2010222756" name=""/>
+          <p:cNvPr id="413656623" name=""/>
           <p:cNvSpPr txBox="1"/>
           <p:nvPr/>
         </p:nvSpPr>
@@ -4608,7 +4694,7 @@
       </p:sp>
       <p:sp>
         <p:nvSpPr>
-          <p:cNvPr id="1213346720" name=""/>
+          <p:cNvPr id="1738926822" name=""/>
           <p:cNvSpPr txBox="1"/>
           <p:nvPr/>
         </p:nvSpPr>
@@ -4640,7 +4726,7 @@
       </p:sp>
       <p:sp>
         <p:nvSpPr>
-          <p:cNvPr id="1370729455" name=""/>
+          <p:cNvPr id="792805039" name=""/>
           <p:cNvSpPr txBox="1"/>
           <p:nvPr/>
         </p:nvSpPr>
@@ -4672,7 +4758,7 @@
       </p:sp>
       <p:sp>
         <p:nvSpPr>
-          <p:cNvPr id="322465998" name=""/>
+          <p:cNvPr id="1124055020" name=""/>
           <p:cNvSpPr txBox="1"/>
           <p:nvPr/>
         </p:nvSpPr>
@@ -4737,7 +4823,7 @@
       </p:grpSpPr>
       <p:sp>
         <p:nvSpPr>
-          <p:cNvPr id="991062146" name="Titel 1"/>
+          <p:cNvPr id="961575256" name="Titel 1"/>
           <p:cNvSpPr>
             <a:spLocks noGrp="1"/>
           </p:cNvSpPr>
@@ -4763,7 +4849,7 @@
       </p:sp>
       <p:sp>
         <p:nvSpPr>
-          <p:cNvPr id="1249923848" name="Inhaltsplatzhalter 2"/>
+          <p:cNvPr id="1464918785" name="Inhaltsplatzhalter 2"/>
           <p:cNvSpPr>
             <a:spLocks noGrp="1"/>
           </p:cNvSpPr>
@@ -4811,7 +4897,7 @@
       </p:sp>
       <p:pic>
         <p:nvPicPr>
-          <p:cNvPr id="1183213548" name=""/>
+          <p:cNvPr id="1540055175" name=""/>
           <p:cNvPicPr>
             <a:picLocks noChangeAspect="1"/>
           </p:cNvPicPr>
@@ -4833,7 +4919,7 @@
       </p:pic>
       <p:pic>
         <p:nvPicPr>
-          <p:cNvPr id="1599267491" name=""/>
+          <p:cNvPr id="1827353986" name=""/>
           <p:cNvPicPr>
             <a:picLocks noChangeAspect="1"/>
           </p:cNvPicPr>
@@ -4888,7 +4974,7 @@
       </p:grpSpPr>
       <p:sp>
         <p:nvSpPr>
-          <p:cNvPr id="1399805942" name="Titel 1"/>
+          <p:cNvPr id="886320704" name="Titel 1"/>
           <p:cNvSpPr>
             <a:spLocks noGrp="1"/>
           </p:cNvSpPr>
@@ -4914,7 +5000,7 @@
       </p:sp>
       <p:pic>
         <p:nvPicPr>
-          <p:cNvPr id="396789985" name=""/>
+          <p:cNvPr id="146592590" name=""/>
           <p:cNvPicPr>
             <a:picLocks noChangeAspect="1"/>
           </p:cNvPicPr>
@@ -4969,7 +5055,7 @@
       </p:grpSpPr>
       <p:sp>
         <p:nvSpPr>
-          <p:cNvPr id="792396006" name="Titel 1"/>
+          <p:cNvPr id="610180080" name="Titel 1"/>
           <p:cNvSpPr>
             <a:spLocks noGrp="1"/>
           </p:cNvSpPr>
@@ -4995,7 +5081,7 @@
       </p:sp>
       <p:sp>
         <p:nvSpPr>
-          <p:cNvPr id="12938144" name="Inhaltsplatzhalter 2"/>
+          <p:cNvPr id="445073158" name="Inhaltsplatzhalter 2"/>
           <p:cNvSpPr>
             <a:spLocks noGrp="1"/>
           </p:cNvSpPr>
@@ -5148,7 +5234,7 @@
       </p:sp>
       <p:pic>
         <p:nvPicPr>
-          <p:cNvPr id="1085506994" name=""/>
+          <p:cNvPr id="1184242974" name=""/>
           <p:cNvPicPr>
             <a:picLocks noChangeAspect="1"/>
           </p:cNvPicPr>
@@ -5170,7 +5256,7 @@
       </p:pic>
       <p:pic>
         <p:nvPicPr>
-          <p:cNvPr id="1235923494" name=""/>
+          <p:cNvPr id="1958227626" name=""/>
           <p:cNvPicPr>
             <a:picLocks noChangeAspect="1"/>
           </p:cNvPicPr>
@@ -5192,7 +5278,7 @@
       </p:pic>
       <p:pic>
         <p:nvPicPr>
-          <p:cNvPr id="1185539368" name=""/>
+          <p:cNvPr id="947382265" name=""/>
           <p:cNvPicPr>
             <a:picLocks noChangeAspect="1"/>
           </p:cNvPicPr>
@@ -5247,7 +5333,7 @@
       </p:grpSpPr>
       <p:sp>
         <p:nvSpPr>
-          <p:cNvPr id="1884106139" name="Titel 1"/>
+          <p:cNvPr id="1079185150" name="Titel 1"/>
           <p:cNvSpPr>
             <a:spLocks noGrp="1"/>
           </p:cNvSpPr>
@@ -5273,7 +5359,7 @@
       </p:sp>
       <p:sp>
         <p:nvSpPr>
-          <p:cNvPr id="853334102" name="Inhaltsplatzhalter 2"/>
+          <p:cNvPr id="1507346976" name="Inhaltsplatzhalter 2"/>
           <p:cNvSpPr>
             <a:spLocks noGrp="1"/>
           </p:cNvSpPr>
@@ -5421,13 +5507,13 @@
       </p:sp>
       <p:sp>
         <p:nvSpPr>
-          <p:cNvPr id="520220212" name=""/>
+          <p:cNvPr id="571893910" name=""/>
           <p:cNvSpPr txBox="1"/>
           <p:nvPr/>
         </p:nvSpPr>
         <p:spPr bwMode="auto">
           <a:xfrm rot="0" flipH="0" flipV="0">
-            <a:off x="838199" y="5810842"/>
+            <a:off x="838198" y="5810842"/>
             <a:ext cx="9630203" cy="366119"/>
           </a:xfrm>
           <a:prstGeom prst="rect">
@@ -5458,6 +5544,91 @@
                 <a:hlinkClick r:id="rId3" tooltip=""/>
               </a:rPr>
               <a:t>https://github.com/Monstroxx/greenhouse</a:t>
+            </a:r>
+            <a:endParaRPr/>
+          </a:p>
+        </p:txBody>
+      </p:sp>
+    </p:spTree>
+  </p:cSld>
+  <p:clrMapOvr>
+    <a:masterClrMapping/>
+  </p:clrMapOvr>
+  <mc:AlternateContent xmlns:mc="http://schemas.openxmlformats.org/markup-compatibility/2006">
+    <mc:Choice xmlns:p159="http://schemas.microsoft.com/office/powerpoint/2015/09/main" xmlns:p14="http://schemas.microsoft.com/office/powerpoint/2010/main" Requires="p159">
+      <p:transition p14:dur="500" advClick="1"/>
+    </mc:Choice>
+    <mc:Fallback>
+      <p:transition advClick="1"/>
+    </mc:Fallback>
+  </mc:AlternateContent>
+</p:sld>
+</file>
+
+<file path=ppt/slides/slide8.xml><?xml version="1.0" encoding="utf-8"?>
+<p:sld xmlns:a="http://schemas.openxmlformats.org/drawingml/2006/main" xmlns:r="http://schemas.openxmlformats.org/officeDocument/2006/relationships" xmlns:p="http://schemas.openxmlformats.org/presentationml/2006/main" xmlns:m="http://schemas.openxmlformats.org/officeDocument/2006/math" xmlns:w="http://schemas.openxmlformats.org/wordprocessingml/2006/main" xmlns:mc="http://schemas.openxmlformats.org/markup-compatibility/2006" showMasterPhAnim="0" showMasterSp="1" show="1">
+  <p:cSld name="">
+    <p:spTree>
+      <p:nvGrpSpPr>
+        <p:cNvPr id="1" name=""/>
+        <p:cNvGrpSpPr/>
+        <p:nvPr/>
+      </p:nvGrpSpPr>
+      <p:grpSpPr bwMode="auto">
+        <a:xfrm>
+          <a:off x="0" y="0"/>
+          <a:ext cx="0" cy="0"/>
+          <a:chOff x="0" y="0"/>
+          <a:chExt cx="0" cy="0"/>
+        </a:xfrm>
+      </p:grpSpPr>
+      <p:sp>
+        <p:nvSpPr>
+          <p:cNvPr id="1598264591" name="Titel 1"/>
+          <p:cNvSpPr>
+            <a:spLocks noGrp="1"/>
+          </p:cNvSpPr>
+          <p:nvPr>
+            <p:ph type="title"/>
+          </p:nvPr>
+        </p:nvSpPr>
+        <p:spPr bwMode="auto"/>
+        <p:txBody>
+          <a:bodyPr/>
+          <a:lstStyle/>
+          <a:p>
+            <a:pPr>
+              <a:defRPr/>
+            </a:pPr>
+            <a:r>
+              <a:rPr/>
+              <a:t>In Action</a:t>
+            </a:r>
+            <a:endParaRPr/>
+          </a:p>
+        </p:txBody>
+      </p:sp>
+      <p:sp>
+        <p:nvSpPr>
+          <p:cNvPr id="1185334306" name="Inhaltsplatzhalter 2"/>
+          <p:cNvSpPr>
+            <a:spLocks noGrp="1"/>
+          </p:cNvSpPr>
+          <p:nvPr>
+            <p:ph idx="1"/>
+          </p:nvPr>
+        </p:nvSpPr>
+        <p:spPr bwMode="auto"/>
+        <p:txBody>
+          <a:bodyPr/>
+          <a:lstStyle/>
+          <a:p>
+            <a:pPr>
+              <a:defRPr/>
+            </a:pPr>
+            <a:r>
+              <a:rPr/>
+              <a:t>See it in real live</a:t>
             </a:r>
             <a:endParaRPr/>
           </a:p>

</xml_diff>

<commit_message>
Wrong information in Presentation fixed
</commit_message>
<xml_diff>
--- a/Greenhouse Presentation.pptx
+++ b/Greenhouse Presentation.pptx
@@ -141,7 +141,7 @@
       </p:grpSpPr>
       <p:sp>
         <p:nvSpPr>
-          <p:cNvPr id="636320813" name="Platzhalter für Überschrift 1"/>
+          <p:cNvPr id="1035849423" name="Platzhalter für Überschrift 1"/>
           <p:cNvSpPr>
             <a:spLocks noGrp="1"/>
           </p:cNvSpPr>
@@ -175,7 +175,7 @@
       </p:sp>
       <p:sp>
         <p:nvSpPr>
-          <p:cNvPr id="74515277" name="Datumsplatzhalter 2"/>
+          <p:cNvPr id="1239825836" name="Datumsplatzhalter 2"/>
           <p:cNvSpPr>
             <a:spLocks noGrp="1"/>
           </p:cNvSpPr>
@@ -213,7 +213,7 @@
       </p:sp>
       <p:sp>
         <p:nvSpPr>
-          <p:cNvPr id="827126978" name="Platzhalter für Folienbilder 3"/>
+          <p:cNvPr id="2086480465" name="Platzhalter für Folienbilder 3"/>
           <p:cNvSpPr>
             <a:spLocks noChangeAspect="1" noGrp="1" noRot="1"/>
           </p:cNvSpPr>
@@ -249,7 +249,7 @@
       </p:sp>
       <p:sp>
         <p:nvSpPr>
-          <p:cNvPr id="1811817901" name="Platzhalter für Notizen 4"/>
+          <p:cNvPr id="655398302" name="Platzhalter für Notizen 4"/>
           <p:cNvSpPr>
             <a:spLocks noGrp="1"/>
           </p:cNvSpPr>
@@ -323,7 +323,7 @@
       </p:sp>
       <p:sp>
         <p:nvSpPr>
-          <p:cNvPr id="1462806288" name="Fußzeilenplatzhalter 5"/>
+          <p:cNvPr id="671437593" name="Fußzeilenplatzhalter 5"/>
           <p:cNvSpPr>
             <a:spLocks noGrp="1"/>
           </p:cNvSpPr>
@@ -357,7 +357,7 @@
       </p:sp>
       <p:sp>
         <p:nvSpPr>
-          <p:cNvPr id="2139191217" name="Foliennummernplatzhalter 6"/>
+          <p:cNvPr id="946795565" name="Foliennummernplatzhalter 6"/>
           <p:cNvSpPr>
             <a:spLocks noGrp="1"/>
           </p:cNvSpPr>
@@ -510,7 +510,7 @@
       </p:grpSpPr>
       <p:sp>
         <p:nvSpPr>
-          <p:cNvPr id="903836805" name="Platzhalter für Folienbild 1"/>
+          <p:cNvPr id="1358225958" name="Platzhalter für Folienbild 1"/>
           <p:cNvSpPr>
             <a:spLocks noChangeAspect="1" noGrp="1" noRot="1"/>
           </p:cNvSpPr>
@@ -527,7 +527,7 @@
       </p:sp>
       <p:sp>
         <p:nvSpPr>
-          <p:cNvPr id="1284366547" name="Platzhalter für Notizen 2"/>
+          <p:cNvPr id="27225799" name="Platzhalter für Notizen 2"/>
           <p:cNvSpPr>
             <a:spLocks noGrp="1"/>
           </p:cNvSpPr>
@@ -559,7 +559,7 @@
       </p:sp>
       <p:sp>
         <p:nvSpPr>
-          <p:cNvPr id="102234563" name="Foliennummernplatzhalter 3"/>
+          <p:cNvPr id="284313525" name="Foliennummernplatzhalter 3"/>
           <p:cNvSpPr>
             <a:spLocks noGrp="1"/>
           </p:cNvSpPr>
@@ -610,7 +610,7 @@
       </p:grpSpPr>
       <p:sp>
         <p:nvSpPr>
-          <p:cNvPr id="1614411872" name="Slide Image Placeholder 1"/>
+          <p:cNvPr id="276862259" name="Slide Image Placeholder 1"/>
           <p:cNvSpPr>
             <a:spLocks noChangeAspect="1" noGrp="1" noRot="1"/>
           </p:cNvSpPr>
@@ -622,7 +622,7 @@
       </p:sp>
       <p:sp>
         <p:nvSpPr>
-          <p:cNvPr id="1410098373" name="Notes Placeholder 2"/>
+          <p:cNvPr id="1537753853" name="Notes Placeholder 2"/>
           <p:cNvSpPr>
             <a:spLocks noGrp="1"/>
           </p:cNvSpPr>
@@ -648,7 +648,7 @@
       </p:sp>
       <p:sp>
         <p:nvSpPr>
-          <p:cNvPr id="1787167157" name="Slide Number Placeholder 3"/>
+          <p:cNvPr id="37500243" name="Slide Number Placeholder 3"/>
           <p:cNvSpPr>
             <a:spLocks noGrp="1"/>
           </p:cNvSpPr>
@@ -699,7 +699,7 @@
       </p:grpSpPr>
       <p:sp>
         <p:nvSpPr>
-          <p:cNvPr id="954758286" name="Slide Image Placeholder 1"/>
+          <p:cNvPr id="2131552043" name="Slide Image Placeholder 1"/>
           <p:cNvSpPr>
             <a:spLocks noChangeAspect="1" noGrp="1" noRot="1"/>
           </p:cNvSpPr>
@@ -711,7 +711,7 @@
       </p:sp>
       <p:sp>
         <p:nvSpPr>
-          <p:cNvPr id="890730262" name="Notes Placeholder 2"/>
+          <p:cNvPr id="182553710" name="Notes Placeholder 2"/>
           <p:cNvSpPr>
             <a:spLocks noGrp="1"/>
           </p:cNvSpPr>
@@ -737,7 +737,7 @@
       </p:sp>
       <p:sp>
         <p:nvSpPr>
-          <p:cNvPr id="1741326101" name="Slide Number Placeholder 3"/>
+          <p:cNvPr id="682939184" name="Slide Number Placeholder 3"/>
           <p:cNvSpPr>
             <a:spLocks noGrp="1"/>
           </p:cNvSpPr>
@@ -788,7 +788,7 @@
       </p:grpSpPr>
       <p:sp>
         <p:nvSpPr>
-          <p:cNvPr id="296850706" name="Slide Image Placeholder 1"/>
+          <p:cNvPr id="1656267975" name="Slide Image Placeholder 1"/>
           <p:cNvSpPr>
             <a:spLocks noChangeAspect="1" noGrp="1" noRot="1"/>
           </p:cNvSpPr>
@@ -800,7 +800,7 @@
       </p:sp>
       <p:sp>
         <p:nvSpPr>
-          <p:cNvPr id="568547133" name="Notes Placeholder 2"/>
+          <p:cNvPr id="2037357648" name="Notes Placeholder 2"/>
           <p:cNvSpPr>
             <a:spLocks noGrp="1"/>
           </p:cNvSpPr>
@@ -826,7 +826,7 @@
       </p:sp>
       <p:sp>
         <p:nvSpPr>
-          <p:cNvPr id="1259010972" name="Slide Number Placeholder 3"/>
+          <p:cNvPr id="965866612" name="Slide Number Placeholder 3"/>
           <p:cNvSpPr>
             <a:spLocks noGrp="1"/>
           </p:cNvSpPr>
@@ -877,7 +877,7 @@
       </p:grpSpPr>
       <p:sp>
         <p:nvSpPr>
-          <p:cNvPr id="330140555" name="Slide Image Placeholder 1"/>
+          <p:cNvPr id="1994868696" name="Slide Image Placeholder 1"/>
           <p:cNvSpPr>
             <a:spLocks noChangeAspect="1" noGrp="1" noRot="1"/>
           </p:cNvSpPr>
@@ -889,7 +889,7 @@
       </p:sp>
       <p:sp>
         <p:nvSpPr>
-          <p:cNvPr id="421487892" name="Notes Placeholder 2"/>
+          <p:cNvPr id="2052246190" name="Notes Placeholder 2"/>
           <p:cNvSpPr>
             <a:spLocks noGrp="1"/>
           </p:cNvSpPr>
@@ -915,7 +915,7 @@
       </p:sp>
       <p:sp>
         <p:nvSpPr>
-          <p:cNvPr id="1440483869" name="Slide Number Placeholder 3"/>
+          <p:cNvPr id="722528852" name="Slide Number Placeholder 3"/>
           <p:cNvSpPr>
             <a:spLocks noGrp="1"/>
           </p:cNvSpPr>
@@ -966,7 +966,7 @@
       </p:grpSpPr>
       <p:sp>
         <p:nvSpPr>
-          <p:cNvPr id="1989523795" name="Slide Image Placeholder 1"/>
+          <p:cNvPr id="487180672" name="Slide Image Placeholder 1"/>
           <p:cNvSpPr>
             <a:spLocks noChangeAspect="1" noGrp="1" noRot="1"/>
           </p:cNvSpPr>
@@ -978,7 +978,7 @@
       </p:sp>
       <p:sp>
         <p:nvSpPr>
-          <p:cNvPr id="159865706" name="Notes Placeholder 2"/>
+          <p:cNvPr id="918747039" name="Notes Placeholder 2"/>
           <p:cNvSpPr>
             <a:spLocks noGrp="1"/>
           </p:cNvSpPr>
@@ -1004,7 +1004,7 @@
       </p:sp>
       <p:sp>
         <p:nvSpPr>
-          <p:cNvPr id="748845142" name="Slide Number Placeholder 3"/>
+          <p:cNvPr id="1300833665" name="Slide Number Placeholder 3"/>
           <p:cNvSpPr>
             <a:spLocks noGrp="1"/>
           </p:cNvSpPr>
@@ -1055,7 +1055,7 @@
       </p:grpSpPr>
       <p:sp>
         <p:nvSpPr>
-          <p:cNvPr id="2103728311" name="Slide Image Placeholder 1"/>
+          <p:cNvPr id="877682847" name="Slide Image Placeholder 1"/>
           <p:cNvSpPr>
             <a:spLocks noChangeAspect="1" noGrp="1" noRot="1"/>
           </p:cNvSpPr>
@@ -1067,7 +1067,7 @@
       </p:sp>
       <p:sp>
         <p:nvSpPr>
-          <p:cNvPr id="626460519" name="Notes Placeholder 2"/>
+          <p:cNvPr id="49235582" name="Notes Placeholder 2"/>
           <p:cNvSpPr>
             <a:spLocks noGrp="1"/>
           </p:cNvSpPr>
@@ -1093,7 +1093,7 @@
       </p:sp>
       <p:sp>
         <p:nvSpPr>
-          <p:cNvPr id="34831422" name="Slide Number Placeholder 3"/>
+          <p:cNvPr id="1382077276" name="Slide Number Placeholder 3"/>
           <p:cNvSpPr>
             <a:spLocks noGrp="1"/>
           </p:cNvSpPr>
@@ -1144,7 +1144,7 @@
       </p:grpSpPr>
       <p:sp>
         <p:nvSpPr>
-          <p:cNvPr id="2" name="Slide Image Placeholder 1"/>
+          <p:cNvPr id="306411373" name="Slide Image Placeholder 1"/>
           <p:cNvSpPr>
             <a:spLocks noChangeAspect="1" noGrp="1" noRot="1"/>
           </p:cNvSpPr>
@@ -1156,7 +1156,7 @@
       </p:sp>
       <p:sp>
         <p:nvSpPr>
-          <p:cNvPr id="3" name="Notes Placeholder 2"/>
+          <p:cNvPr id="2050819775" name="Notes Placeholder 2"/>
           <p:cNvSpPr>
             <a:spLocks noGrp="1"/>
           </p:cNvSpPr>
@@ -1182,7 +1182,7 @@
       </p:sp>
       <p:sp>
         <p:nvSpPr>
-          <p:cNvPr id="4" name="Slide Number Placeholder 3"/>
+          <p:cNvPr id="651614443" name="Slide Number Placeholder 3"/>
           <p:cNvSpPr>
             <a:spLocks noGrp="1"/>
           </p:cNvSpPr>
@@ -1233,7 +1233,7 @@
       </p:grpSpPr>
       <p:sp>
         <p:nvSpPr>
-          <p:cNvPr id="1987335277" name="Titel 1"/>
+          <p:cNvPr id="901370789" name="Titel 1"/>
           <p:cNvSpPr>
             <a:spLocks noGrp="1"/>
           </p:cNvSpPr>
@@ -1268,7 +1268,7 @@
       </p:sp>
       <p:sp>
         <p:nvSpPr>
-          <p:cNvPr id="1403405257" name="Untertitel 2"/>
+          <p:cNvPr id="1556196198" name="Untertitel 2"/>
           <p:cNvSpPr>
             <a:spLocks noGrp="1"/>
           </p:cNvSpPr>
@@ -1336,7 +1336,7 @@
       </p:sp>
       <p:sp>
         <p:nvSpPr>
-          <p:cNvPr id="247672982" name="Datumsplatzhalter 3"/>
+          <p:cNvPr id="642941338" name="Datumsplatzhalter 3"/>
           <p:cNvSpPr>
             <a:spLocks noGrp="1"/>
           </p:cNvSpPr>
@@ -1362,7 +1362,7 @@
       </p:sp>
       <p:sp>
         <p:nvSpPr>
-          <p:cNvPr id="230531503" name="Fußzeilenplatzhalter 4"/>
+          <p:cNvPr id="813184513" name="Fußzeilenplatzhalter 4"/>
           <p:cNvSpPr>
             <a:spLocks noGrp="1"/>
           </p:cNvSpPr>
@@ -1384,7 +1384,7 @@
       </p:sp>
       <p:sp>
         <p:nvSpPr>
-          <p:cNvPr id="1431738024" name="Foliennummernplatzhalter 5"/>
+          <p:cNvPr id="820457005" name="Foliennummernplatzhalter 5"/>
           <p:cNvSpPr>
             <a:spLocks noGrp="1"/>
           </p:cNvSpPr>
@@ -1435,7 +1435,7 @@
       </p:grpSpPr>
       <p:sp>
         <p:nvSpPr>
-          <p:cNvPr id="1189020220" name="Titel 1"/>
+          <p:cNvPr id="1413120475" name="Titel 1"/>
           <p:cNvSpPr>
             <a:spLocks noGrp="1"/>
           </p:cNvSpPr>
@@ -1461,7 +1461,7 @@
       </p:sp>
       <p:sp>
         <p:nvSpPr>
-          <p:cNvPr id="1439617087" name="Vertikaler Textplatzhalter 2"/>
+          <p:cNvPr id="572162592" name="Vertikaler Textplatzhalter 2"/>
           <p:cNvSpPr>
             <a:spLocks noGrp="1"/>
           </p:cNvSpPr>
@@ -1527,7 +1527,7 @@
       </p:sp>
       <p:sp>
         <p:nvSpPr>
-          <p:cNvPr id="613194477" name="Datumsplatzhalter 3"/>
+          <p:cNvPr id="346845122" name="Datumsplatzhalter 3"/>
           <p:cNvSpPr>
             <a:spLocks noGrp="1"/>
           </p:cNvSpPr>
@@ -1553,7 +1553,7 @@
       </p:sp>
       <p:sp>
         <p:nvSpPr>
-          <p:cNvPr id="2108713113" name="Fußzeilenplatzhalter 4"/>
+          <p:cNvPr id="312683927" name="Fußzeilenplatzhalter 4"/>
           <p:cNvSpPr>
             <a:spLocks noGrp="1"/>
           </p:cNvSpPr>
@@ -1575,7 +1575,7 @@
       </p:sp>
       <p:sp>
         <p:nvSpPr>
-          <p:cNvPr id="1748512760" name="Foliennummernplatzhalter 5"/>
+          <p:cNvPr id="1186524999" name="Foliennummernplatzhalter 5"/>
           <p:cNvSpPr>
             <a:spLocks noGrp="1"/>
           </p:cNvSpPr>
@@ -1626,7 +1626,7 @@
       </p:grpSpPr>
       <p:sp>
         <p:nvSpPr>
-          <p:cNvPr id="2067758750" name="Vertikaler Titel 1"/>
+          <p:cNvPr id="1201718037" name="Vertikaler Titel 1"/>
           <p:cNvSpPr>
             <a:spLocks noGrp="1"/>
           </p:cNvSpPr>
@@ -1657,7 +1657,7 @@
       </p:sp>
       <p:sp>
         <p:nvSpPr>
-          <p:cNvPr id="480453848" name="Vertikaler Textplatzhalter 2"/>
+          <p:cNvPr id="341658583" name="Vertikaler Textplatzhalter 2"/>
           <p:cNvSpPr>
             <a:spLocks noGrp="1"/>
           </p:cNvSpPr>
@@ -1728,7 +1728,7 @@
       </p:sp>
       <p:sp>
         <p:nvSpPr>
-          <p:cNvPr id="1815485799" name="Datumsplatzhalter 3"/>
+          <p:cNvPr id="797272704" name="Datumsplatzhalter 3"/>
           <p:cNvSpPr>
             <a:spLocks noGrp="1"/>
           </p:cNvSpPr>
@@ -1754,7 +1754,7 @@
       </p:sp>
       <p:sp>
         <p:nvSpPr>
-          <p:cNvPr id="812492015" name="Fußzeilenplatzhalter 4"/>
+          <p:cNvPr id="600208252" name="Fußzeilenplatzhalter 4"/>
           <p:cNvSpPr>
             <a:spLocks noGrp="1"/>
           </p:cNvSpPr>
@@ -1776,7 +1776,7 @@
       </p:sp>
       <p:sp>
         <p:nvSpPr>
-          <p:cNvPr id="528259217" name="Foliennummernplatzhalter 5"/>
+          <p:cNvPr id="914977147" name="Foliennummernplatzhalter 5"/>
           <p:cNvSpPr>
             <a:spLocks noGrp="1"/>
           </p:cNvSpPr>
@@ -1827,7 +1827,7 @@
       </p:grpSpPr>
       <p:sp>
         <p:nvSpPr>
-          <p:cNvPr id="1254226579" name="Titel 1"/>
+          <p:cNvPr id="305113432" name="Titel 1"/>
           <p:cNvSpPr>
             <a:spLocks noGrp="1"/>
           </p:cNvSpPr>
@@ -1853,7 +1853,7 @@
       </p:sp>
       <p:sp>
         <p:nvSpPr>
-          <p:cNvPr id="1533170462" name="Inhaltsplatzhalter 2"/>
+          <p:cNvPr id="395932450" name="Inhaltsplatzhalter 2"/>
           <p:cNvSpPr>
             <a:spLocks noGrp="1"/>
           </p:cNvSpPr>
@@ -1919,7 +1919,7 @@
       </p:sp>
       <p:sp>
         <p:nvSpPr>
-          <p:cNvPr id="1904099332" name="Datumsplatzhalter 3"/>
+          <p:cNvPr id="1936161660" name="Datumsplatzhalter 3"/>
           <p:cNvSpPr>
             <a:spLocks noGrp="1"/>
           </p:cNvSpPr>
@@ -1945,7 +1945,7 @@
       </p:sp>
       <p:sp>
         <p:nvSpPr>
-          <p:cNvPr id="1083427801" name="Fußzeilenplatzhalter 4"/>
+          <p:cNvPr id="1125501185" name="Fußzeilenplatzhalter 4"/>
           <p:cNvSpPr>
             <a:spLocks noGrp="1"/>
           </p:cNvSpPr>
@@ -1967,7 +1967,7 @@
       </p:sp>
       <p:sp>
         <p:nvSpPr>
-          <p:cNvPr id="1336573847" name="Foliennummernplatzhalter 5"/>
+          <p:cNvPr id="1982023606" name="Foliennummernplatzhalter 5"/>
           <p:cNvSpPr>
             <a:spLocks noGrp="1"/>
           </p:cNvSpPr>
@@ -2018,7 +2018,7 @@
       </p:grpSpPr>
       <p:sp>
         <p:nvSpPr>
-          <p:cNvPr id="3032178" name="Titel 1"/>
+          <p:cNvPr id="774830685" name="Titel 1"/>
           <p:cNvSpPr>
             <a:spLocks noGrp="1"/>
           </p:cNvSpPr>
@@ -2053,7 +2053,7 @@
       </p:sp>
       <p:sp>
         <p:nvSpPr>
-          <p:cNvPr id="112521013" name="Textplatzhalter 2"/>
+          <p:cNvPr id="984920424" name="Textplatzhalter 2"/>
           <p:cNvSpPr>
             <a:spLocks noGrp="1"/>
           </p:cNvSpPr>
@@ -2175,7 +2175,7 @@
       </p:sp>
       <p:sp>
         <p:nvSpPr>
-          <p:cNvPr id="742996199" name="Datumsplatzhalter 3"/>
+          <p:cNvPr id="306380077" name="Datumsplatzhalter 3"/>
           <p:cNvSpPr>
             <a:spLocks noGrp="1"/>
           </p:cNvSpPr>
@@ -2201,7 +2201,7 @@
       </p:sp>
       <p:sp>
         <p:nvSpPr>
-          <p:cNvPr id="814862026" name="Fußzeilenplatzhalter 4"/>
+          <p:cNvPr id="310069756" name="Fußzeilenplatzhalter 4"/>
           <p:cNvSpPr>
             <a:spLocks noGrp="1"/>
           </p:cNvSpPr>
@@ -2223,7 +2223,7 @@
       </p:sp>
       <p:sp>
         <p:nvSpPr>
-          <p:cNvPr id="570201211" name="Foliennummernplatzhalter 5"/>
+          <p:cNvPr id="787150211" name="Foliennummernplatzhalter 5"/>
           <p:cNvSpPr>
             <a:spLocks noGrp="1"/>
           </p:cNvSpPr>
@@ -2274,7 +2274,7 @@
       </p:grpSpPr>
       <p:sp>
         <p:nvSpPr>
-          <p:cNvPr id="1573508944" name="Titel 1"/>
+          <p:cNvPr id="1422930502" name="Titel 1"/>
           <p:cNvSpPr>
             <a:spLocks noGrp="1"/>
           </p:cNvSpPr>
@@ -2300,7 +2300,7 @@
       </p:sp>
       <p:sp>
         <p:nvSpPr>
-          <p:cNvPr id="896703343" name="Inhaltsplatzhalter 2"/>
+          <p:cNvPr id="1761264034" name="Inhaltsplatzhalter 2"/>
           <p:cNvSpPr>
             <a:spLocks noGrp="1"/>
           </p:cNvSpPr>
@@ -2371,7 +2371,7 @@
       </p:sp>
       <p:sp>
         <p:nvSpPr>
-          <p:cNvPr id="854448201" name="Inhaltsplatzhalter 3"/>
+          <p:cNvPr id="2133737370" name="Inhaltsplatzhalter 3"/>
           <p:cNvSpPr>
             <a:spLocks noGrp="1"/>
           </p:cNvSpPr>
@@ -2442,7 +2442,7 @@
       </p:sp>
       <p:sp>
         <p:nvSpPr>
-          <p:cNvPr id="181477607" name="Datumsplatzhalter 4"/>
+          <p:cNvPr id="1562945731" name="Datumsplatzhalter 4"/>
           <p:cNvSpPr>
             <a:spLocks noGrp="1"/>
           </p:cNvSpPr>
@@ -2468,7 +2468,7 @@
       </p:sp>
       <p:sp>
         <p:nvSpPr>
-          <p:cNvPr id="490043598" name="Fußzeilenplatzhalter 5"/>
+          <p:cNvPr id="478208005" name="Fußzeilenplatzhalter 5"/>
           <p:cNvSpPr>
             <a:spLocks noGrp="1"/>
           </p:cNvSpPr>
@@ -2490,7 +2490,7 @@
       </p:sp>
       <p:sp>
         <p:nvSpPr>
-          <p:cNvPr id="194765213" name="Foliennummernplatzhalter 6"/>
+          <p:cNvPr id="239183886" name="Foliennummernplatzhalter 6"/>
           <p:cNvSpPr>
             <a:spLocks noGrp="1"/>
           </p:cNvSpPr>
@@ -2541,7 +2541,7 @@
       </p:grpSpPr>
       <p:sp>
         <p:nvSpPr>
-          <p:cNvPr id="83329325" name="Titel 1"/>
+          <p:cNvPr id="1885717244" name="Titel 1"/>
           <p:cNvSpPr>
             <a:spLocks noGrp="1"/>
           </p:cNvSpPr>
@@ -2572,7 +2572,7 @@
       </p:sp>
       <p:sp>
         <p:nvSpPr>
-          <p:cNvPr id="1538418718" name="Textplatzhalter 2"/>
+          <p:cNvPr id="1028883554" name="Textplatzhalter 2"/>
           <p:cNvSpPr>
             <a:spLocks noGrp="1"/>
           </p:cNvSpPr>
@@ -2640,7 +2640,7 @@
       </p:sp>
       <p:sp>
         <p:nvSpPr>
-          <p:cNvPr id="1277235932" name="Inhaltsplatzhalter 3"/>
+          <p:cNvPr id="454568876" name="Inhaltsplatzhalter 3"/>
           <p:cNvSpPr>
             <a:spLocks noGrp="1"/>
           </p:cNvSpPr>
@@ -2711,7 +2711,7 @@
       </p:sp>
       <p:sp>
         <p:nvSpPr>
-          <p:cNvPr id="1400613041" name="Textplatzhalter 4"/>
+          <p:cNvPr id="761545598" name="Textplatzhalter 4"/>
           <p:cNvSpPr>
             <a:spLocks noGrp="1"/>
           </p:cNvSpPr>
@@ -2779,7 +2779,7 @@
       </p:sp>
       <p:sp>
         <p:nvSpPr>
-          <p:cNvPr id="1014720219" name="Inhaltsplatzhalter 5"/>
+          <p:cNvPr id="2065227955" name="Inhaltsplatzhalter 5"/>
           <p:cNvSpPr>
             <a:spLocks noGrp="1"/>
           </p:cNvSpPr>
@@ -2850,7 +2850,7 @@
       </p:sp>
       <p:sp>
         <p:nvSpPr>
-          <p:cNvPr id="863939881" name="Datumsplatzhalter 6"/>
+          <p:cNvPr id="74216055" name="Datumsplatzhalter 6"/>
           <p:cNvSpPr>
             <a:spLocks noGrp="1"/>
           </p:cNvSpPr>
@@ -2876,7 +2876,7 @@
       </p:sp>
       <p:sp>
         <p:nvSpPr>
-          <p:cNvPr id="1236531296" name="Fußzeilenplatzhalter 7"/>
+          <p:cNvPr id="587533260" name="Fußzeilenplatzhalter 7"/>
           <p:cNvSpPr>
             <a:spLocks noGrp="1"/>
           </p:cNvSpPr>
@@ -2898,7 +2898,7 @@
       </p:sp>
       <p:sp>
         <p:nvSpPr>
-          <p:cNvPr id="460568707" name="Foliennummernplatzhalter 8"/>
+          <p:cNvPr id="117950898" name="Foliennummernplatzhalter 8"/>
           <p:cNvSpPr>
             <a:spLocks noGrp="1"/>
           </p:cNvSpPr>
@@ -2949,7 +2949,7 @@
       </p:grpSpPr>
       <p:sp>
         <p:nvSpPr>
-          <p:cNvPr id="940135557" name="Titel 1"/>
+          <p:cNvPr id="1077895504" name="Titel 1"/>
           <p:cNvSpPr>
             <a:spLocks noGrp="1"/>
           </p:cNvSpPr>
@@ -2975,7 +2975,7 @@
       </p:sp>
       <p:sp>
         <p:nvSpPr>
-          <p:cNvPr id="765323599" name="Datumsplatzhalter 2"/>
+          <p:cNvPr id="1145438774" name="Datumsplatzhalter 2"/>
           <p:cNvSpPr>
             <a:spLocks noGrp="1"/>
           </p:cNvSpPr>
@@ -3001,7 +3001,7 @@
       </p:sp>
       <p:sp>
         <p:nvSpPr>
-          <p:cNvPr id="199704346" name="Fußzeilenplatzhalter 3"/>
+          <p:cNvPr id="1352900062" name="Fußzeilenplatzhalter 3"/>
           <p:cNvSpPr>
             <a:spLocks noGrp="1"/>
           </p:cNvSpPr>
@@ -3023,7 +3023,7 @@
       </p:sp>
       <p:sp>
         <p:nvSpPr>
-          <p:cNvPr id="1883107652" name="Foliennummernplatzhalter 4"/>
+          <p:cNvPr id="858869518" name="Foliennummernplatzhalter 4"/>
           <p:cNvSpPr>
             <a:spLocks noGrp="1"/>
           </p:cNvSpPr>
@@ -3074,7 +3074,7 @@
       </p:grpSpPr>
       <p:sp>
         <p:nvSpPr>
-          <p:cNvPr id="1159041277" name="Datumsplatzhalter 1"/>
+          <p:cNvPr id="77249884" name="Datumsplatzhalter 1"/>
           <p:cNvSpPr>
             <a:spLocks noGrp="1"/>
           </p:cNvSpPr>
@@ -3100,7 +3100,7 @@
       </p:sp>
       <p:sp>
         <p:nvSpPr>
-          <p:cNvPr id="1816262845" name="Fußzeilenplatzhalter 2"/>
+          <p:cNvPr id="2121328865" name="Fußzeilenplatzhalter 2"/>
           <p:cNvSpPr>
             <a:spLocks noGrp="1"/>
           </p:cNvSpPr>
@@ -3122,7 +3122,7 @@
       </p:sp>
       <p:sp>
         <p:nvSpPr>
-          <p:cNvPr id="638773093" name="Foliennummernplatzhalter 3"/>
+          <p:cNvPr id="1865137869" name="Foliennummernplatzhalter 3"/>
           <p:cNvSpPr>
             <a:spLocks noGrp="1"/>
           </p:cNvSpPr>
@@ -3173,7 +3173,7 @@
       </p:grpSpPr>
       <p:sp>
         <p:nvSpPr>
-          <p:cNvPr id="569580387" name="Titel 1"/>
+          <p:cNvPr id="321600436" name="Titel 1"/>
           <p:cNvSpPr>
             <a:spLocks noGrp="1"/>
           </p:cNvSpPr>
@@ -3208,7 +3208,7 @@
       </p:sp>
       <p:sp>
         <p:nvSpPr>
-          <p:cNvPr id="866138342" name="Inhaltsplatzhalter 2"/>
+          <p:cNvPr id="642131752" name="Inhaltsplatzhalter 2"/>
           <p:cNvSpPr>
             <a:spLocks noGrp="1"/>
           </p:cNvSpPr>
@@ -3307,7 +3307,7 @@
       </p:sp>
       <p:sp>
         <p:nvSpPr>
-          <p:cNvPr id="5505303" name="Textplatzhalter 3"/>
+          <p:cNvPr id="759306304" name="Textplatzhalter 3"/>
           <p:cNvSpPr>
             <a:spLocks noGrp="1"/>
           </p:cNvSpPr>
@@ -3375,7 +3375,7 @@
       </p:sp>
       <p:sp>
         <p:nvSpPr>
-          <p:cNvPr id="870175036" name="Datumsplatzhalter 4"/>
+          <p:cNvPr id="1754146189" name="Datumsplatzhalter 4"/>
           <p:cNvSpPr>
             <a:spLocks noGrp="1"/>
           </p:cNvSpPr>
@@ -3401,7 +3401,7 @@
       </p:sp>
       <p:sp>
         <p:nvSpPr>
-          <p:cNvPr id="1894462679" name="Fußzeilenplatzhalter 5"/>
+          <p:cNvPr id="1574093820" name="Fußzeilenplatzhalter 5"/>
           <p:cNvSpPr>
             <a:spLocks noGrp="1"/>
           </p:cNvSpPr>
@@ -3423,7 +3423,7 @@
       </p:sp>
       <p:sp>
         <p:nvSpPr>
-          <p:cNvPr id="2049672200" name="Foliennummernplatzhalter 6"/>
+          <p:cNvPr id="1273145541" name="Foliennummernplatzhalter 6"/>
           <p:cNvSpPr>
             <a:spLocks noGrp="1"/>
           </p:cNvSpPr>
@@ -3474,7 +3474,7 @@
       </p:grpSpPr>
       <p:sp>
         <p:nvSpPr>
-          <p:cNvPr id="432399452" name="Titel 1"/>
+          <p:cNvPr id="648383203" name="Titel 1"/>
           <p:cNvSpPr>
             <a:spLocks noGrp="1"/>
           </p:cNvSpPr>
@@ -3509,7 +3509,7 @@
       </p:sp>
       <p:sp>
         <p:nvSpPr>
-          <p:cNvPr id="1236203286" name="Bildplatzhalter 2"/>
+          <p:cNvPr id="91245671" name="Bildplatzhalter 2"/>
           <p:cNvSpPr>
             <a:spLocks noChangeAspect="1" noGrp="1"/>
           </p:cNvSpPr>
@@ -3577,7 +3577,7 @@
       </p:sp>
       <p:sp>
         <p:nvSpPr>
-          <p:cNvPr id="335337333" name="Textplatzhalter 3"/>
+          <p:cNvPr id="968948076" name="Textplatzhalter 3"/>
           <p:cNvSpPr>
             <a:spLocks noGrp="1"/>
           </p:cNvSpPr>
@@ -3645,7 +3645,7 @@
       </p:sp>
       <p:sp>
         <p:nvSpPr>
-          <p:cNvPr id="700486114" name="Datumsplatzhalter 4"/>
+          <p:cNvPr id="936800016" name="Datumsplatzhalter 4"/>
           <p:cNvSpPr>
             <a:spLocks noGrp="1"/>
           </p:cNvSpPr>
@@ -3671,7 +3671,7 @@
       </p:sp>
       <p:sp>
         <p:nvSpPr>
-          <p:cNvPr id="1078178208" name="Fußzeilenplatzhalter 5"/>
+          <p:cNvPr id="2115007986" name="Fußzeilenplatzhalter 5"/>
           <p:cNvSpPr>
             <a:spLocks noGrp="1"/>
           </p:cNvSpPr>
@@ -3693,7 +3693,7 @@
       </p:sp>
       <p:sp>
         <p:nvSpPr>
-          <p:cNvPr id="1453666270" name="Foliennummernplatzhalter 6"/>
+          <p:cNvPr id="498407122" name="Foliennummernplatzhalter 6"/>
           <p:cNvSpPr>
             <a:spLocks noGrp="1"/>
           </p:cNvSpPr>
@@ -3749,7 +3749,7 @@
       </p:grpSpPr>
       <p:sp>
         <p:nvSpPr>
-          <p:cNvPr id="488438476" name="Titelplatzhalter 1"/>
+          <p:cNvPr id="1256237666" name="Titelplatzhalter 1"/>
           <p:cNvSpPr>
             <a:spLocks noGrp="1"/>
           </p:cNvSpPr>
@@ -3785,7 +3785,7 @@
       </p:sp>
       <p:sp>
         <p:nvSpPr>
-          <p:cNvPr id="10075324" name="Textplatzhalter 2"/>
+          <p:cNvPr id="1883844707" name="Textplatzhalter 2"/>
           <p:cNvSpPr>
             <a:spLocks noGrp="1"/>
           </p:cNvSpPr>
@@ -3861,7 +3861,7 @@
       </p:sp>
       <p:sp>
         <p:nvSpPr>
-          <p:cNvPr id="592635118" name="Datumsplatzhalter 3"/>
+          <p:cNvPr id="2033596685" name="Datumsplatzhalter 3"/>
           <p:cNvSpPr>
             <a:spLocks noGrp="1"/>
           </p:cNvSpPr>
@@ -3905,7 +3905,7 @@
       </p:sp>
       <p:sp>
         <p:nvSpPr>
-          <p:cNvPr id="1887224140" name="Fußzeilenplatzhalter 4"/>
+          <p:cNvPr id="1747303610" name="Fußzeilenplatzhalter 4"/>
           <p:cNvSpPr>
             <a:spLocks noGrp="1"/>
           </p:cNvSpPr>
@@ -3945,7 +3945,7 @@
       </p:sp>
       <p:sp>
         <p:nvSpPr>
-          <p:cNvPr id="1885152678" name="Foliennummernplatzhalter 5"/>
+          <p:cNvPr id="1837458877" name="Foliennummernplatzhalter 5"/>
           <p:cNvSpPr>
             <a:spLocks noGrp="1"/>
           </p:cNvSpPr>
@@ -4305,7 +4305,7 @@
       </p:grpSpPr>
       <p:sp>
         <p:nvSpPr>
-          <p:cNvPr id="1980114720" name="Titel 1"/>
+          <p:cNvPr id="1448674251" name="Titel 1"/>
           <p:cNvSpPr>
             <a:spLocks noGrp="1"/>
           </p:cNvSpPr>
@@ -4331,7 +4331,7 @@
       </p:sp>
       <p:sp>
         <p:nvSpPr>
-          <p:cNvPr id="2029453072" name="Untertitel 2"/>
+          <p:cNvPr id="1162724629" name="Untertitel 2"/>
           <p:cNvSpPr>
             <a:spLocks noGrp="1"/>
           </p:cNvSpPr>
@@ -4390,7 +4390,7 @@
       </p:grpSpPr>
       <p:sp>
         <p:nvSpPr>
-          <p:cNvPr id="2077242010" name="Titel 1"/>
+          <p:cNvPr id="1536011854" name="Titel 1"/>
           <p:cNvSpPr>
             <a:spLocks noGrp="1"/>
           </p:cNvSpPr>
@@ -4416,7 +4416,7 @@
       </p:sp>
       <p:pic>
         <p:nvPicPr>
-          <p:cNvPr id="315968612" name=""/>
+          <p:cNvPr id="840641761" name=""/>
           <p:cNvPicPr>
             <a:picLocks noChangeAspect="1"/>
           </p:cNvPicPr>
@@ -4438,7 +4438,7 @@
       </p:pic>
       <p:sp>
         <p:nvSpPr>
-          <p:cNvPr id="2074044882" name=""/>
+          <p:cNvPr id="332482389" name=""/>
           <p:cNvSpPr txBox="1"/>
           <p:nvPr/>
         </p:nvSpPr>
@@ -4529,7 +4529,7 @@
       </p:grpSpPr>
       <p:sp>
         <p:nvSpPr>
-          <p:cNvPr id="836414074" name="Titel 1"/>
+          <p:cNvPr id="1908501109" name="Titel 1"/>
           <p:cNvSpPr>
             <a:spLocks noGrp="1"/>
           </p:cNvSpPr>
@@ -4555,7 +4555,7 @@
       </p:sp>
       <p:pic>
         <p:nvPicPr>
-          <p:cNvPr id="2088708168" name=""/>
+          <p:cNvPr id="487160604" name=""/>
           <p:cNvPicPr>
             <a:picLocks noChangeAspect="1"/>
           </p:cNvPicPr>
@@ -4577,7 +4577,7 @@
       </p:pic>
       <p:pic>
         <p:nvPicPr>
-          <p:cNvPr id="1087256027" name=""/>
+          <p:cNvPr id="1667440659" name=""/>
           <p:cNvPicPr>
             <a:picLocks noChangeAspect="1"/>
           </p:cNvPicPr>
@@ -4599,7 +4599,7 @@
       </p:pic>
       <p:pic>
         <p:nvPicPr>
-          <p:cNvPr id="448757916" name=""/>
+          <p:cNvPr id="1610674971" name=""/>
           <p:cNvPicPr>
             <a:picLocks noChangeAspect="1"/>
           </p:cNvPicPr>
@@ -4621,7 +4621,7 @@
       </p:pic>
       <p:pic>
         <p:nvPicPr>
-          <p:cNvPr id="1229814183" name=""/>
+          <p:cNvPr id="640968181" name=""/>
           <p:cNvPicPr>
             <a:picLocks noChangeAspect="1"/>
           </p:cNvPicPr>
@@ -4643,7 +4643,7 @@
       </p:pic>
       <p:pic>
         <p:nvPicPr>
-          <p:cNvPr id="820034903" name=""/>
+          <p:cNvPr id="936187336" name=""/>
           <p:cNvPicPr>
             <a:picLocks noChangeAspect="1"/>
           </p:cNvPicPr>
@@ -4665,7 +4665,7 @@
       </p:pic>
       <p:sp>
         <p:nvSpPr>
-          <p:cNvPr id="154641769" name=""/>
+          <p:cNvPr id="1306277987" name=""/>
           <p:cNvSpPr txBox="1"/>
           <p:nvPr/>
         </p:nvSpPr>
@@ -4697,7 +4697,7 @@
       </p:sp>
       <p:sp>
         <p:nvSpPr>
-          <p:cNvPr id="285227435" name=""/>
+          <p:cNvPr id="372731818" name=""/>
           <p:cNvSpPr txBox="1"/>
           <p:nvPr/>
         </p:nvSpPr>
@@ -4729,7 +4729,7 @@
       </p:sp>
       <p:sp>
         <p:nvSpPr>
-          <p:cNvPr id="936895506" name=""/>
+          <p:cNvPr id="1165821182" name=""/>
           <p:cNvSpPr txBox="1"/>
           <p:nvPr/>
         </p:nvSpPr>
@@ -4761,7 +4761,7 @@
       </p:sp>
       <p:sp>
         <p:nvSpPr>
-          <p:cNvPr id="1187908033" name=""/>
+          <p:cNvPr id="82786564" name=""/>
           <p:cNvSpPr txBox="1"/>
           <p:nvPr/>
         </p:nvSpPr>
@@ -4793,7 +4793,7 @@
       </p:sp>
       <p:sp>
         <p:nvSpPr>
-          <p:cNvPr id="1141191215" name=""/>
+          <p:cNvPr id="144292303" name=""/>
           <p:cNvSpPr txBox="1"/>
           <p:nvPr/>
         </p:nvSpPr>
@@ -4858,7 +4858,7 @@
       </p:grpSpPr>
       <p:sp>
         <p:nvSpPr>
-          <p:cNvPr id="1740744435" name="Titel 1"/>
+          <p:cNvPr id="2058837243" name="Titel 1"/>
           <p:cNvSpPr>
             <a:spLocks noGrp="1"/>
           </p:cNvSpPr>
@@ -4884,7 +4884,7 @@
       </p:sp>
       <p:sp>
         <p:nvSpPr>
-          <p:cNvPr id="381632859" name="Inhaltsplatzhalter 2"/>
+          <p:cNvPr id="1325476089" name="Inhaltsplatzhalter 2"/>
           <p:cNvSpPr>
             <a:spLocks noGrp="1"/>
           </p:cNvSpPr>
@@ -4932,7 +4932,7 @@
       </p:sp>
       <p:pic>
         <p:nvPicPr>
-          <p:cNvPr id="259977740" name=""/>
+          <p:cNvPr id="1087243612" name=""/>
           <p:cNvPicPr>
             <a:picLocks noChangeAspect="1"/>
           </p:cNvPicPr>
@@ -4954,7 +4954,7 @@
       </p:pic>
       <p:pic>
         <p:nvPicPr>
-          <p:cNvPr id="590809926" name=""/>
+          <p:cNvPr id="900196341" name=""/>
           <p:cNvPicPr>
             <a:picLocks noChangeAspect="1"/>
           </p:cNvPicPr>
@@ -5009,7 +5009,7 @@
       </p:grpSpPr>
       <p:sp>
         <p:nvSpPr>
-          <p:cNvPr id="1307174206" name="Titel 1"/>
+          <p:cNvPr id="1270738585" name="Titel 1"/>
           <p:cNvSpPr>
             <a:spLocks noGrp="1"/>
           </p:cNvSpPr>
@@ -5035,7 +5035,7 @@
       </p:sp>
       <p:pic>
         <p:nvPicPr>
-          <p:cNvPr id="282553379" name=""/>
+          <p:cNvPr id="1793009108" name=""/>
           <p:cNvPicPr>
             <a:picLocks noChangeAspect="1"/>
           </p:cNvPicPr>
@@ -5090,7 +5090,7 @@
       </p:grpSpPr>
       <p:sp>
         <p:nvSpPr>
-          <p:cNvPr id="735632341" name="Titel 1"/>
+          <p:cNvPr id="1105638303" name="Titel 1"/>
           <p:cNvSpPr>
             <a:spLocks noGrp="1"/>
           </p:cNvSpPr>
@@ -5116,7 +5116,7 @@
       </p:sp>
       <p:sp>
         <p:nvSpPr>
-          <p:cNvPr id="186812827" name="Inhaltsplatzhalter 2"/>
+          <p:cNvPr id="494503328" name="Inhaltsplatzhalter 2"/>
           <p:cNvSpPr>
             <a:spLocks noGrp="1"/>
           </p:cNvSpPr>
@@ -5127,7 +5127,7 @@
         <p:spPr bwMode="auto"/>
         <p:txBody>
           <a:bodyPr vertOverflow="overflow" horzOverflow="overflow" vert="horz" wrap="square" lIns="91440" tIns="45720" rIns="91440" bIns="45720" numCol="1" spcCol="0" rtlCol="0" fromWordArt="0" anchor="t" anchorCtr="0" forceAA="0" upright="0" compatLnSpc="0">
-            <a:normAutofit/>
+            <a:normAutofit fontScale="90000" lnSpcReduction="2000"/>
           </a:bodyPr>
           <a:lstStyle/>
           <a:p>
@@ -5187,7 +5187,31 @@
                 <a:ea typeface="+mn-ea"/>
                 <a:cs typeface="+mn-cs"/>
               </a:rPr>
-              <a:t>Air Pressure</a:t>
+              <a:t>Soil messurement</a:t>
+            </a:r>
+            <a:endParaRPr lang="de-DE" sz="2400" b="0" i="0" u="none" strike="noStrike" cap="none" spc="0">
+              <a:solidFill>
+                <a:schemeClr val="tx1"/>
+              </a:solidFill>
+              <a:latin typeface="Arial"/>
+              <a:ea typeface="Arial"/>
+              <a:cs typeface="Arial"/>
+            </a:endParaRPr>
+          </a:p>
+          <a:p>
+            <a:pPr lvl="1">
+              <a:defRPr/>
+            </a:pPr>
+            <a:r>
+              <a:rPr lang="de-DE" sz="2400" b="0" i="0" u="none" strike="noStrike" cap="none" spc="0">
+                <a:solidFill>
+                  <a:schemeClr val="tx1"/>
+                </a:solidFill>
+                <a:latin typeface="Arial"/>
+                <a:ea typeface="Arial"/>
+                <a:cs typeface="Arial"/>
+              </a:rPr>
+              <a:t>Light level</a:t>
             </a:r>
             <a:endParaRPr/>
           </a:p>
@@ -5269,7 +5293,7 @@
       </p:sp>
       <p:pic>
         <p:nvPicPr>
-          <p:cNvPr id="250331253" name=""/>
+          <p:cNvPr id="807104370" name=""/>
           <p:cNvPicPr>
             <a:picLocks noChangeAspect="1"/>
           </p:cNvPicPr>
@@ -5291,7 +5315,7 @@
       </p:pic>
       <p:pic>
         <p:nvPicPr>
-          <p:cNvPr id="1380892686" name=""/>
+          <p:cNvPr id="2004216715" name=""/>
           <p:cNvPicPr>
             <a:picLocks noChangeAspect="1"/>
           </p:cNvPicPr>
@@ -5313,7 +5337,7 @@
       </p:pic>
       <p:pic>
         <p:nvPicPr>
-          <p:cNvPr id="1647833031" name=""/>
+          <p:cNvPr id="337591613" name=""/>
           <p:cNvPicPr>
             <a:picLocks noChangeAspect="1"/>
           </p:cNvPicPr>
@@ -5368,7 +5392,7 @@
       </p:grpSpPr>
       <p:sp>
         <p:nvSpPr>
-          <p:cNvPr id="237128600" name="Titel 1"/>
+          <p:cNvPr id="1283977590" name="Titel 1"/>
           <p:cNvSpPr>
             <a:spLocks noGrp="1"/>
           </p:cNvSpPr>
@@ -5394,7 +5418,7 @@
       </p:sp>
       <p:sp>
         <p:nvSpPr>
-          <p:cNvPr id="2082727014" name="Inhaltsplatzhalter 2"/>
+          <p:cNvPr id="1356162247" name="Inhaltsplatzhalter 2"/>
           <p:cNvSpPr>
             <a:spLocks noGrp="1"/>
           </p:cNvSpPr>
@@ -5542,7 +5566,7 @@
       </p:sp>
       <p:sp>
         <p:nvSpPr>
-          <p:cNvPr id="1279713597" name=""/>
+          <p:cNvPr id="529524885" name=""/>
           <p:cNvSpPr txBox="1"/>
           <p:nvPr/>
         </p:nvSpPr>
@@ -5619,7 +5643,7 @@
       </p:grpSpPr>
       <p:sp>
         <p:nvSpPr>
-          <p:cNvPr id="1598264591" name="Titel 1"/>
+          <p:cNvPr id="856332102" name="Titel 1"/>
           <p:cNvSpPr>
             <a:spLocks noGrp="1"/>
           </p:cNvSpPr>
@@ -5645,7 +5669,7 @@
       </p:sp>
       <p:sp>
         <p:nvSpPr>
-          <p:cNvPr id="1185334306" name="Inhaltsplatzhalter 2"/>
+          <p:cNvPr id="1805311561" name="Inhaltsplatzhalter 2"/>
           <p:cNvSpPr>
             <a:spLocks noGrp="1"/>
           </p:cNvSpPr>

</xml_diff>